<commit_message>
Deck v4 — Discover/Assess/Enforce terminology on capabilities slide
Co-Authored-By: Claude Sonnet 4.6 <noreply@anthropic.com>
</commit_message>
<xml_diff>
--- a/artifacts/eng-prekickoff-2026-04-27.pptx
+++ b/artifacts/eng-prekickoff-2026-04-27.pptx
@@ -2724,7 +2724,7 @@
                 <a:ea typeface="Georgia" pitchFamily="34" charset="-122"/>
                 <a:cs typeface="Georgia" pitchFamily="34" charset="-120"/>
               </a:rPr>
-              <a:t>What “agent IAM” actually means.</a:t>
+              <a:t>10 capabilities. Three stages.</a:t>
             </a:r>
             <a:endParaRPr lang="en-US" sz="3400" dirty="0"/>
           </a:p>
@@ -2732,53 +2732,14 @@
       </p:sp>
       <p:sp>
         <p:nvSpPr>
-          <p:cNvPr id="5" name="Text 3"/>
-          <p:cNvSpPr/>
-          <p:nvPr/>
-        </p:nvSpPr>
-        <p:spPr>
-          <a:xfrm>
-            <a:off x="457200" y="1600200"/>
-            <a:ext cx="8229600" cy="320040"/>
-          </a:xfrm>
-          <a:prstGeom prst="rect">
-            <a:avLst/>
-          </a:prstGeom>
-          <a:noFill/>
-          <a:ln/>
-        </p:spPr>
-        <p:txBody>
-          <a:bodyPr wrap="square" lIns="0" tIns="0" rIns="0" bIns="0" rtlCol="0" anchor="ctr"/>
-          <a:lstStyle/>
-          <a:p>
-            <a:pPr indent="0" marL="0">
-              <a:buNone/>
-            </a:pPr>
-            <a:r>
-              <a:rPr lang="en-US" sz="1200" i="1" dirty="0">
-                <a:solidFill>
-                  <a:srgbClr val="64748B"/>
-                </a:solidFill>
-                <a:latin typeface="Calibri" pitchFamily="34" charset="0"/>
-                <a:ea typeface="Calibri" pitchFamily="34" charset="-122"/>
-                <a:cs typeface="Calibri" pitchFamily="34" charset="-120"/>
-              </a:rPr>
-              <a:t>10-capability framework (“IAM for LLM-Based AI Agents”). Grouped by theme — not phases.</a:t>
-            </a:r>
-            <a:endParaRPr lang="en-US" sz="1200" dirty="0"/>
-          </a:p>
-        </p:txBody>
-      </p:sp>
-      <p:sp>
-        <p:nvSpPr>
-          <p:cNvPr id="6" name="Shape 4"/>
-          <p:cNvSpPr/>
-          <p:nvPr/>
-        </p:nvSpPr>
-        <p:spPr>
-          <a:xfrm>
-            <a:off x="365760" y="2011680"/>
-            <a:ext cx="2743200" cy="384048"/>
+          <p:cNvPr id="5" name="Shape 3"/>
+          <p:cNvSpPr/>
+          <p:nvPr/>
+        </p:nvSpPr>
+        <p:spPr>
+          <a:xfrm>
+            <a:off x="365760" y="1691640"/>
+            <a:ext cx="2743200" cy="411480"/>
           </a:xfrm>
           <a:prstGeom prst="rect">
             <a:avLst/>
@@ -2796,14 +2757,14 @@
       </p:sp>
       <p:sp>
         <p:nvSpPr>
-          <p:cNvPr id="7" name="Text 5"/>
-          <p:cNvSpPr/>
-          <p:nvPr/>
-        </p:nvSpPr>
-        <p:spPr>
-          <a:xfrm>
-            <a:off x="365760" y="2011680"/>
-            <a:ext cx="2743200" cy="384048"/>
+          <p:cNvPr id="6" name="Text 4"/>
+          <p:cNvSpPr/>
+          <p:nvPr/>
+        </p:nvSpPr>
+        <p:spPr>
+          <a:xfrm>
+            <a:off x="365760" y="1691640"/>
+            <a:ext cx="2743200" cy="411480"/>
           </a:xfrm>
           <a:prstGeom prst="rect">
             <a:avLst/>
@@ -2819,7 +2780,7 @@
               <a:buNone/>
             </a:pPr>
             <a:r>
-              <a:rPr lang="en-US" sz="1300" b="1" spc="400" kern="0" dirty="0">
+              <a:rPr lang="en-US" sz="1400" b="1" spc="500" kern="0" dirty="0">
                 <a:solidFill>
                   <a:srgbClr val="FFFFFF"/>
                 </a:solidFill>
@@ -2827,22 +2788,22 @@
                 <a:ea typeface="Calibri" pitchFamily="34" charset="-122"/>
                 <a:cs typeface="Calibri" pitchFamily="34" charset="-120"/>
               </a:rPr>
-              <a:t>VISIBILITY</a:t>
-            </a:r>
-            <a:endParaRPr lang="en-US" sz="1300" dirty="0"/>
-          </a:p>
-        </p:txBody>
-      </p:sp>
-      <p:sp>
-        <p:nvSpPr>
-          <p:cNvPr id="8" name="Shape 6"/>
-          <p:cNvSpPr/>
-          <p:nvPr/>
-        </p:nvSpPr>
-        <p:spPr>
-          <a:xfrm>
-            <a:off x="365760" y="2395728"/>
-            <a:ext cx="2743200" cy="2176272"/>
+              <a:t>DISCOVER</a:t>
+            </a:r>
+            <a:endParaRPr lang="en-US" sz="1400" dirty="0"/>
+          </a:p>
+        </p:txBody>
+      </p:sp>
+      <p:sp>
+        <p:nvSpPr>
+          <p:cNvPr id="7" name="Shape 5"/>
+          <p:cNvSpPr/>
+          <p:nvPr/>
+        </p:nvSpPr>
+        <p:spPr>
+          <a:xfrm>
+            <a:off x="365760" y="2103120"/>
+            <a:ext cx="2743200" cy="2468880"/>
           </a:xfrm>
           <a:prstGeom prst="rect">
             <a:avLst/>
@@ -2860,14 +2821,14 @@
       </p:sp>
       <p:sp>
         <p:nvSpPr>
-          <p:cNvPr id="9" name="Shape 7"/>
-          <p:cNvSpPr/>
-          <p:nvPr/>
-        </p:nvSpPr>
-        <p:spPr>
-          <a:xfrm>
-            <a:off x="548640" y="2551176"/>
-            <a:ext cx="274320" cy="274320"/>
+          <p:cNvPr id="8" name="Shape 6"/>
+          <p:cNvSpPr/>
+          <p:nvPr/>
+        </p:nvSpPr>
+        <p:spPr>
+          <a:xfrm>
+            <a:off x="548640" y="2295144"/>
+            <a:ext cx="256032" cy="256032"/>
           </a:xfrm>
           <a:prstGeom prst="ellipse">
             <a:avLst/>
@@ -2885,53 +2846,53 @@
       </p:sp>
       <p:sp>
         <p:nvSpPr>
+          <p:cNvPr id="9" name="Text 7"/>
+          <p:cNvSpPr/>
+          <p:nvPr/>
+        </p:nvSpPr>
+        <p:spPr>
+          <a:xfrm>
+            <a:off x="548640" y="2295144"/>
+            <a:ext cx="256032" cy="256032"/>
+          </a:xfrm>
+          <a:prstGeom prst="rect">
+            <a:avLst/>
+          </a:prstGeom>
+          <a:noFill/>
+          <a:ln/>
+        </p:spPr>
+        <p:txBody>
+          <a:bodyPr wrap="square" lIns="0" tIns="0" rIns="0" bIns="0" rtlCol="0" anchor="ctr"/>
+          <a:lstStyle/>
+          <a:p>
+            <a:pPr algn="ctr" indent="0" marL="0">
+              <a:buNone/>
+            </a:pPr>
+            <a:r>
+              <a:rPr lang="en-US" sz="1000" b="1" dirty="0">
+                <a:solidFill>
+                  <a:srgbClr val="FFFFFF"/>
+                </a:solidFill>
+                <a:latin typeface="Calibri" pitchFamily="34" charset="0"/>
+                <a:ea typeface="Calibri" pitchFamily="34" charset="-122"/>
+                <a:cs typeface="Calibri" pitchFamily="34" charset="-120"/>
+              </a:rPr>
+              <a:t>1</a:t>
+            </a:r>
+            <a:endParaRPr lang="en-US" sz="1000" dirty="0"/>
+          </a:p>
+        </p:txBody>
+      </p:sp>
+      <p:sp>
+        <p:nvSpPr>
           <p:cNvPr id="10" name="Text 8"/>
           <p:cNvSpPr/>
           <p:nvPr/>
         </p:nvSpPr>
         <p:spPr>
           <a:xfrm>
-            <a:off x="548640" y="2551176"/>
-            <a:ext cx="274320" cy="274320"/>
-          </a:xfrm>
-          <a:prstGeom prst="rect">
-            <a:avLst/>
-          </a:prstGeom>
-          <a:noFill/>
-          <a:ln/>
-        </p:spPr>
-        <p:txBody>
-          <a:bodyPr wrap="square" lIns="0" tIns="0" rIns="0" bIns="0" rtlCol="0" anchor="ctr"/>
-          <a:lstStyle/>
-          <a:p>
-            <a:pPr algn="ctr" indent="0" marL="0">
-              <a:buNone/>
-            </a:pPr>
-            <a:r>
-              <a:rPr lang="en-US" sz="1100" b="1" dirty="0">
-                <a:solidFill>
-                  <a:srgbClr val="FFFFFF"/>
-                </a:solidFill>
-                <a:latin typeface="Calibri" pitchFamily="34" charset="0"/>
-                <a:ea typeface="Calibri" pitchFamily="34" charset="-122"/>
-                <a:cs typeface="Calibri" pitchFamily="34" charset="-120"/>
-              </a:rPr>
-              <a:t>1</a:t>
-            </a:r>
-            <a:endParaRPr lang="en-US" sz="1100" dirty="0"/>
-          </a:p>
-        </p:txBody>
-      </p:sp>
-      <p:sp>
-        <p:nvSpPr>
-          <p:cNvPr id="11" name="Text 9"/>
-          <p:cNvSpPr/>
-          <p:nvPr/>
-        </p:nvSpPr>
-        <p:spPr>
-          <a:xfrm>
-            <a:off x="914400" y="2514600"/>
-            <a:ext cx="2057400" cy="384048"/>
+            <a:off x="896112" y="2240280"/>
+            <a:ext cx="2084832" cy="457200"/>
           </a:xfrm>
           <a:prstGeom prst="rect">
             <a:avLst/>
@@ -2963,14 +2924,14 @@
       </p:sp>
       <p:sp>
         <p:nvSpPr>
-          <p:cNvPr id="12" name="Shape 10"/>
-          <p:cNvSpPr/>
-          <p:nvPr/>
-        </p:nvSpPr>
-        <p:spPr>
-          <a:xfrm>
-            <a:off x="548640" y="3072384"/>
-            <a:ext cx="274320" cy="274320"/>
+          <p:cNvPr id="11" name="Shape 9"/>
+          <p:cNvSpPr/>
+          <p:nvPr/>
+        </p:nvSpPr>
+        <p:spPr>
+          <a:xfrm>
+            <a:off x="548640" y="2880360"/>
+            <a:ext cx="256032" cy="256032"/>
           </a:xfrm>
           <a:prstGeom prst="ellipse">
             <a:avLst/>
@@ -2988,53 +2949,53 @@
       </p:sp>
       <p:sp>
         <p:nvSpPr>
+          <p:cNvPr id="12" name="Text 10"/>
+          <p:cNvSpPr/>
+          <p:nvPr/>
+        </p:nvSpPr>
+        <p:spPr>
+          <a:xfrm>
+            <a:off x="548640" y="2880360"/>
+            <a:ext cx="256032" cy="256032"/>
+          </a:xfrm>
+          <a:prstGeom prst="rect">
+            <a:avLst/>
+          </a:prstGeom>
+          <a:noFill/>
+          <a:ln/>
+        </p:spPr>
+        <p:txBody>
+          <a:bodyPr wrap="square" lIns="0" tIns="0" rIns="0" bIns="0" rtlCol="0" anchor="ctr"/>
+          <a:lstStyle/>
+          <a:p>
+            <a:pPr algn="ctr" indent="0" marL="0">
+              <a:buNone/>
+            </a:pPr>
+            <a:r>
+              <a:rPr lang="en-US" sz="1000" b="1" dirty="0">
+                <a:solidFill>
+                  <a:srgbClr val="FFFFFF"/>
+                </a:solidFill>
+                <a:latin typeface="Calibri" pitchFamily="34" charset="0"/>
+                <a:ea typeface="Calibri" pitchFamily="34" charset="-122"/>
+                <a:cs typeface="Calibri" pitchFamily="34" charset="-120"/>
+              </a:rPr>
+              <a:t>2</a:t>
+            </a:r>
+            <a:endParaRPr lang="en-US" sz="1000" dirty="0"/>
+          </a:p>
+        </p:txBody>
+      </p:sp>
+      <p:sp>
+        <p:nvSpPr>
           <p:cNvPr id="13" name="Text 11"/>
           <p:cNvSpPr/>
           <p:nvPr/>
         </p:nvSpPr>
         <p:spPr>
           <a:xfrm>
-            <a:off x="548640" y="3072384"/>
-            <a:ext cx="274320" cy="274320"/>
-          </a:xfrm>
-          <a:prstGeom prst="rect">
-            <a:avLst/>
-          </a:prstGeom>
-          <a:noFill/>
-          <a:ln/>
-        </p:spPr>
-        <p:txBody>
-          <a:bodyPr wrap="square" lIns="0" tIns="0" rIns="0" bIns="0" rtlCol="0" anchor="ctr"/>
-          <a:lstStyle/>
-          <a:p>
-            <a:pPr algn="ctr" indent="0" marL="0">
-              <a:buNone/>
-            </a:pPr>
-            <a:r>
-              <a:rPr lang="en-US" sz="1100" b="1" dirty="0">
-                <a:solidFill>
-                  <a:srgbClr val="FFFFFF"/>
-                </a:solidFill>
-                <a:latin typeface="Calibri" pitchFamily="34" charset="0"/>
-                <a:ea typeface="Calibri" pitchFamily="34" charset="-122"/>
-                <a:cs typeface="Calibri" pitchFamily="34" charset="-120"/>
-              </a:rPr>
-              <a:t>2</a:t>
-            </a:r>
-            <a:endParaRPr lang="en-US" sz="1100" dirty="0"/>
-          </a:p>
-        </p:txBody>
-      </p:sp>
-      <p:sp>
-        <p:nvSpPr>
-          <p:cNvPr id="14" name="Text 12"/>
-          <p:cNvSpPr/>
-          <p:nvPr/>
-        </p:nvSpPr>
-        <p:spPr>
-          <a:xfrm>
-            <a:off x="914400" y="3035808"/>
-            <a:ext cx="2057400" cy="384048"/>
+            <a:off x="896112" y="2825496"/>
+            <a:ext cx="2084832" cy="457200"/>
           </a:xfrm>
           <a:prstGeom prst="rect">
             <a:avLst/>
@@ -3066,14 +3027,14 @@
       </p:sp>
       <p:sp>
         <p:nvSpPr>
-          <p:cNvPr id="15" name="Shape 13"/>
-          <p:cNvSpPr/>
-          <p:nvPr/>
-        </p:nvSpPr>
-        <p:spPr>
-          <a:xfrm>
-            <a:off x="548640" y="3593592"/>
-            <a:ext cx="274320" cy="274320"/>
+          <p:cNvPr id="14" name="Shape 12"/>
+          <p:cNvSpPr/>
+          <p:nvPr/>
+        </p:nvSpPr>
+        <p:spPr>
+          <a:xfrm>
+            <a:off x="548640" y="3465576"/>
+            <a:ext cx="256032" cy="256032"/>
           </a:xfrm>
           <a:prstGeom prst="ellipse">
             <a:avLst/>
@@ -3091,53 +3052,53 @@
       </p:sp>
       <p:sp>
         <p:nvSpPr>
+          <p:cNvPr id="15" name="Text 13"/>
+          <p:cNvSpPr/>
+          <p:nvPr/>
+        </p:nvSpPr>
+        <p:spPr>
+          <a:xfrm>
+            <a:off x="548640" y="3465576"/>
+            <a:ext cx="256032" cy="256032"/>
+          </a:xfrm>
+          <a:prstGeom prst="rect">
+            <a:avLst/>
+          </a:prstGeom>
+          <a:noFill/>
+          <a:ln/>
+        </p:spPr>
+        <p:txBody>
+          <a:bodyPr wrap="square" lIns="0" tIns="0" rIns="0" bIns="0" rtlCol="0" anchor="ctr"/>
+          <a:lstStyle/>
+          <a:p>
+            <a:pPr algn="ctr" indent="0" marL="0">
+              <a:buNone/>
+            </a:pPr>
+            <a:r>
+              <a:rPr lang="en-US" sz="1000" b="1" dirty="0">
+                <a:solidFill>
+                  <a:srgbClr val="FFFFFF"/>
+                </a:solidFill>
+                <a:latin typeface="Calibri" pitchFamily="34" charset="0"/>
+                <a:ea typeface="Calibri" pitchFamily="34" charset="-122"/>
+                <a:cs typeface="Calibri" pitchFamily="34" charset="-120"/>
+              </a:rPr>
+              <a:t>10</a:t>
+            </a:r>
+            <a:endParaRPr lang="en-US" sz="1000" dirty="0"/>
+          </a:p>
+        </p:txBody>
+      </p:sp>
+      <p:sp>
+        <p:nvSpPr>
           <p:cNvPr id="16" name="Text 14"/>
           <p:cNvSpPr/>
           <p:nvPr/>
         </p:nvSpPr>
         <p:spPr>
           <a:xfrm>
-            <a:off x="548640" y="3593592"/>
-            <a:ext cx="274320" cy="274320"/>
-          </a:xfrm>
-          <a:prstGeom prst="rect">
-            <a:avLst/>
-          </a:prstGeom>
-          <a:noFill/>
-          <a:ln/>
-        </p:spPr>
-        <p:txBody>
-          <a:bodyPr wrap="square" lIns="0" tIns="0" rIns="0" bIns="0" rtlCol="0" anchor="ctr"/>
-          <a:lstStyle/>
-          <a:p>
-            <a:pPr algn="ctr" indent="0" marL="0">
-              <a:buNone/>
-            </a:pPr>
-            <a:r>
-              <a:rPr lang="en-US" sz="1100" b="1" dirty="0">
-                <a:solidFill>
-                  <a:srgbClr val="FFFFFF"/>
-                </a:solidFill>
-                <a:latin typeface="Calibri" pitchFamily="34" charset="0"/>
-                <a:ea typeface="Calibri" pitchFamily="34" charset="-122"/>
-                <a:cs typeface="Calibri" pitchFamily="34" charset="-120"/>
-              </a:rPr>
-              <a:t>3</a:t>
-            </a:r>
-            <a:endParaRPr lang="en-US" sz="1100" dirty="0"/>
-          </a:p>
-        </p:txBody>
-      </p:sp>
-      <p:sp>
-        <p:nvSpPr>
-          <p:cNvPr id="17" name="Text 15"/>
-          <p:cNvSpPr/>
-          <p:nvPr/>
-        </p:nvSpPr>
-        <p:spPr>
-          <a:xfrm>
-            <a:off x="914400" y="3557016"/>
-            <a:ext cx="2057400" cy="384048"/>
+            <a:off x="896112" y="3410712"/>
+            <a:ext cx="2084832" cy="457200"/>
           </a:xfrm>
           <a:prstGeom prst="rect">
             <a:avLst/>
@@ -3161,7 +3122,7 @@
                 <a:ea typeface="Calibri" pitchFamily="34" charset="-122"/>
                 <a:cs typeface="Calibri" pitchFamily="34" charset="-120"/>
               </a:rPr>
-              <a:t>Authentication</a:t>
+              <a:t>Visibility &amp; observability</a:t>
             </a:r>
             <a:endParaRPr lang="en-US" sz="1200" dirty="0"/>
           </a:p>
@@ -3169,117 +3130,38 @@
       </p:sp>
       <p:sp>
         <p:nvSpPr>
-          <p:cNvPr id="18" name="Shape 16"/>
-          <p:cNvSpPr/>
-          <p:nvPr/>
-        </p:nvSpPr>
-        <p:spPr>
-          <a:xfrm>
-            <a:off x="548640" y="4114800"/>
-            <a:ext cx="274320" cy="274320"/>
-          </a:xfrm>
-          <a:prstGeom prst="ellipse">
-            <a:avLst/>
-          </a:prstGeom>
-          <a:solidFill>
-            <a:srgbClr val="02C39A"/>
-          </a:solidFill>
-          <a:ln w="12700">
+          <p:cNvPr id="17" name="Shape 15"/>
+          <p:cNvSpPr/>
+          <p:nvPr/>
+        </p:nvSpPr>
+        <p:spPr>
+          <a:xfrm>
+            <a:off x="3118104" y="1892808"/>
+            <a:ext cx="82296" cy="0"/>
+          </a:xfrm>
+          <a:prstGeom prst="line">
+            <a:avLst/>
+          </a:prstGeom>
+          <a:noFill/>
+          <a:ln w="25400">
             <a:solidFill>
-              <a:srgbClr val="02C39A"/>
+              <a:srgbClr val="FFFFFF"/>
             </a:solidFill>
             <a:prstDash val="solid"/>
+            <a:tailEnd type="triangle"/>
           </a:ln>
         </p:spPr>
       </p:sp>
       <p:sp>
         <p:nvSpPr>
-          <p:cNvPr id="19" name="Text 17"/>
-          <p:cNvSpPr/>
-          <p:nvPr/>
-        </p:nvSpPr>
-        <p:spPr>
-          <a:xfrm>
-            <a:off x="548640" y="4114800"/>
-            <a:ext cx="274320" cy="274320"/>
-          </a:xfrm>
-          <a:prstGeom prst="rect">
-            <a:avLst/>
-          </a:prstGeom>
-          <a:noFill/>
-          <a:ln/>
-        </p:spPr>
-        <p:txBody>
-          <a:bodyPr wrap="square" lIns="0" tIns="0" rIns="0" bIns="0" rtlCol="0" anchor="ctr"/>
-          <a:lstStyle/>
-          <a:p>
-            <a:pPr algn="ctr" indent="0" marL="0">
-              <a:buNone/>
-            </a:pPr>
-            <a:r>
-              <a:rPr lang="en-US" sz="1100" b="1" dirty="0">
-                <a:solidFill>
-                  <a:srgbClr val="FFFFFF"/>
-                </a:solidFill>
-                <a:latin typeface="Calibri" pitchFamily="34" charset="0"/>
-                <a:ea typeface="Calibri" pitchFamily="34" charset="-122"/>
-                <a:cs typeface="Calibri" pitchFamily="34" charset="-120"/>
-              </a:rPr>
-              <a:t>10</a:t>
-            </a:r>
-            <a:endParaRPr lang="en-US" sz="1100" dirty="0"/>
-          </a:p>
-        </p:txBody>
-      </p:sp>
-      <p:sp>
-        <p:nvSpPr>
-          <p:cNvPr id="20" name="Text 18"/>
-          <p:cNvSpPr/>
-          <p:nvPr/>
-        </p:nvSpPr>
-        <p:spPr>
-          <a:xfrm>
-            <a:off x="914400" y="4078224"/>
-            <a:ext cx="2057400" cy="384048"/>
-          </a:xfrm>
-          <a:prstGeom prst="rect">
-            <a:avLst/>
-          </a:prstGeom>
-          <a:noFill/>
-          <a:ln/>
-        </p:spPr>
-        <p:txBody>
-          <a:bodyPr wrap="square" lIns="0" tIns="0" rIns="0" bIns="0" rtlCol="0" anchor="ctr"/>
-          <a:lstStyle/>
-          <a:p>
-            <a:pPr indent="0" marL="0">
-              <a:buNone/>
-            </a:pPr>
-            <a:r>
-              <a:rPr lang="en-US" sz="1200" dirty="0">
-                <a:solidFill>
-                  <a:srgbClr val="1A1F36"/>
-                </a:solidFill>
-                <a:latin typeface="Calibri" pitchFamily="34" charset="0"/>
-                <a:ea typeface="Calibri" pitchFamily="34" charset="-122"/>
-                <a:cs typeface="Calibri" pitchFamily="34" charset="-120"/>
-              </a:rPr>
-              <a:t>Visibility &amp; observability</a:t>
-            </a:r>
-            <a:endParaRPr lang="en-US" sz="1200" dirty="0"/>
-          </a:p>
-        </p:txBody>
-      </p:sp>
-      <p:sp>
-        <p:nvSpPr>
-          <p:cNvPr id="21" name="Shape 19"/>
-          <p:cNvSpPr/>
-          <p:nvPr/>
-        </p:nvSpPr>
-        <p:spPr>
-          <a:xfrm>
-            <a:off x="3200400" y="2011680"/>
-            <a:ext cx="2743200" cy="384048"/>
+          <p:cNvPr id="18" name="Shape 16"/>
+          <p:cNvSpPr/>
+          <p:nvPr/>
+        </p:nvSpPr>
+        <p:spPr>
+          <a:xfrm>
+            <a:off x="3200400" y="1691640"/>
+            <a:ext cx="2743200" cy="411480"/>
           </a:xfrm>
           <a:prstGeom prst="rect">
             <a:avLst/>
@@ -3297,14 +3179,14 @@
       </p:sp>
       <p:sp>
         <p:nvSpPr>
-          <p:cNvPr id="22" name="Text 20"/>
-          <p:cNvSpPr/>
-          <p:nvPr/>
-        </p:nvSpPr>
-        <p:spPr>
-          <a:xfrm>
-            <a:off x="3200400" y="2011680"/>
-            <a:ext cx="2743200" cy="384048"/>
+          <p:cNvPr id="19" name="Text 17"/>
+          <p:cNvSpPr/>
+          <p:nvPr/>
+        </p:nvSpPr>
+        <p:spPr>
+          <a:xfrm>
+            <a:off x="3200400" y="1691640"/>
+            <a:ext cx="2743200" cy="411480"/>
           </a:xfrm>
           <a:prstGeom prst="rect">
             <a:avLst/>
@@ -3320,7 +3202,7 @@
               <a:buNone/>
             </a:pPr>
             <a:r>
-              <a:rPr lang="en-US" sz="1300" b="1" spc="400" kern="0" dirty="0">
+              <a:rPr lang="en-US" sz="1400" b="1" spc="500" kern="0" dirty="0">
                 <a:solidFill>
                   <a:srgbClr val="FFFFFF"/>
                 </a:solidFill>
@@ -3328,22 +3210,22 @@
                 <a:ea typeface="Calibri" pitchFamily="34" charset="-122"/>
                 <a:cs typeface="Calibri" pitchFamily="34" charset="-120"/>
               </a:rPr>
-              <a:t>CONTROL</a:t>
-            </a:r>
-            <a:endParaRPr lang="en-US" sz="1300" dirty="0"/>
-          </a:p>
-        </p:txBody>
-      </p:sp>
-      <p:sp>
-        <p:nvSpPr>
-          <p:cNvPr id="23" name="Shape 21"/>
-          <p:cNvSpPr/>
-          <p:nvPr/>
-        </p:nvSpPr>
-        <p:spPr>
-          <a:xfrm>
-            <a:off x="3200400" y="2395728"/>
-            <a:ext cx="2743200" cy="2176272"/>
+              <a:t>ASSESS</a:t>
+            </a:r>
+            <a:endParaRPr lang="en-US" sz="1400" dirty="0"/>
+          </a:p>
+        </p:txBody>
+      </p:sp>
+      <p:sp>
+        <p:nvSpPr>
+          <p:cNvPr id="20" name="Shape 18"/>
+          <p:cNvSpPr/>
+          <p:nvPr/>
+        </p:nvSpPr>
+        <p:spPr>
+          <a:xfrm>
+            <a:off x="3200400" y="2103120"/>
+            <a:ext cx="2743200" cy="2468880"/>
           </a:xfrm>
           <a:prstGeom prst="rect">
             <a:avLst/>
@@ -3361,14 +3243,14 @@
       </p:sp>
       <p:sp>
         <p:nvSpPr>
-          <p:cNvPr id="24" name="Shape 22"/>
-          <p:cNvSpPr/>
-          <p:nvPr/>
-        </p:nvSpPr>
-        <p:spPr>
-          <a:xfrm>
-            <a:off x="3383280" y="2551176"/>
-            <a:ext cx="274320" cy="274320"/>
+          <p:cNvPr id="21" name="Shape 19"/>
+          <p:cNvSpPr/>
+          <p:nvPr/>
+        </p:nvSpPr>
+        <p:spPr>
+          <a:xfrm>
+            <a:off x="3383280" y="2295144"/>
+            <a:ext cx="256032" cy="256032"/>
           </a:xfrm>
           <a:prstGeom prst="ellipse">
             <a:avLst/>
@@ -3386,14 +3268,14 @@
       </p:sp>
       <p:sp>
         <p:nvSpPr>
-          <p:cNvPr id="25" name="Text 23"/>
-          <p:cNvSpPr/>
-          <p:nvPr/>
-        </p:nvSpPr>
-        <p:spPr>
-          <a:xfrm>
-            <a:off x="3383280" y="2551176"/>
-            <a:ext cx="274320" cy="274320"/>
+          <p:cNvPr id="22" name="Text 20"/>
+          <p:cNvSpPr/>
+          <p:nvPr/>
+        </p:nvSpPr>
+        <p:spPr>
+          <a:xfrm>
+            <a:off x="3383280" y="2295144"/>
+            <a:ext cx="256032" cy="256032"/>
           </a:xfrm>
           <a:prstGeom prst="rect">
             <a:avLst/>
@@ -3409,7 +3291,7 @@
               <a:buNone/>
             </a:pPr>
             <a:r>
-              <a:rPr lang="en-US" sz="1100" b="1" dirty="0">
+              <a:rPr lang="en-US" sz="1000" b="1" dirty="0">
                 <a:solidFill>
                   <a:srgbClr val="FFFFFF"/>
                 </a:solidFill>
@@ -3417,22 +3299,22 @@
                 <a:ea typeface="Calibri" pitchFamily="34" charset="-122"/>
                 <a:cs typeface="Calibri" pitchFamily="34" charset="-120"/>
               </a:rPr>
-              <a:t>4</a:t>
-            </a:r>
-            <a:endParaRPr lang="en-US" sz="1100" dirty="0"/>
-          </a:p>
-        </p:txBody>
-      </p:sp>
-      <p:sp>
-        <p:nvSpPr>
-          <p:cNvPr id="26" name="Text 24"/>
-          <p:cNvSpPr/>
-          <p:nvPr/>
-        </p:nvSpPr>
-        <p:spPr>
-          <a:xfrm>
-            <a:off x="3749040" y="2514600"/>
-            <a:ext cx="2057400" cy="384048"/>
+              <a:t>3</a:t>
+            </a:r>
+            <a:endParaRPr lang="en-US" sz="1000" dirty="0"/>
+          </a:p>
+        </p:txBody>
+      </p:sp>
+      <p:sp>
+        <p:nvSpPr>
+          <p:cNvPr id="23" name="Text 21"/>
+          <p:cNvSpPr/>
+          <p:nvPr/>
+        </p:nvSpPr>
+        <p:spPr>
+          <a:xfrm>
+            <a:off x="3730752" y="2240280"/>
+            <a:ext cx="2084832" cy="457200"/>
           </a:xfrm>
           <a:prstGeom prst="rect">
             <a:avLst/>
@@ -3456,7 +3338,7 @@
                 <a:ea typeface="Calibri" pitchFamily="34" charset="-122"/>
                 <a:cs typeface="Calibri" pitchFamily="34" charset="-120"/>
               </a:rPr>
-              <a:t>Authorization &amp; delegation</a:t>
+              <a:t>Authentication</a:t>
             </a:r>
             <a:endParaRPr lang="en-US" sz="1200" dirty="0"/>
           </a:p>
@@ -3464,14 +3346,14 @@
       </p:sp>
       <p:sp>
         <p:nvSpPr>
-          <p:cNvPr id="27" name="Shape 25"/>
-          <p:cNvSpPr/>
-          <p:nvPr/>
-        </p:nvSpPr>
-        <p:spPr>
-          <a:xfrm>
-            <a:off x="3383280" y="3072384"/>
-            <a:ext cx="274320" cy="274320"/>
+          <p:cNvPr id="24" name="Shape 22"/>
+          <p:cNvSpPr/>
+          <p:nvPr/>
+        </p:nvSpPr>
+        <p:spPr>
+          <a:xfrm>
+            <a:off x="3383280" y="2880360"/>
+            <a:ext cx="256032" cy="256032"/>
           </a:xfrm>
           <a:prstGeom prst="ellipse">
             <a:avLst/>
@@ -3489,14 +3371,14 @@
       </p:sp>
       <p:sp>
         <p:nvSpPr>
-          <p:cNvPr id="28" name="Text 26"/>
-          <p:cNvSpPr/>
-          <p:nvPr/>
-        </p:nvSpPr>
-        <p:spPr>
-          <a:xfrm>
-            <a:off x="3383280" y="3072384"/>
-            <a:ext cx="274320" cy="274320"/>
+          <p:cNvPr id="25" name="Text 23"/>
+          <p:cNvSpPr/>
+          <p:nvPr/>
+        </p:nvSpPr>
+        <p:spPr>
+          <a:xfrm>
+            <a:off x="3383280" y="2880360"/>
+            <a:ext cx="256032" cy="256032"/>
           </a:xfrm>
           <a:prstGeom prst="rect">
             <a:avLst/>
@@ -3512,7 +3394,7 @@
               <a:buNone/>
             </a:pPr>
             <a:r>
-              <a:rPr lang="en-US" sz="1100" b="1" dirty="0">
+              <a:rPr lang="en-US" sz="1000" b="1" dirty="0">
                 <a:solidFill>
                   <a:srgbClr val="FFFFFF"/>
                 </a:solidFill>
@@ -3520,22 +3402,22 @@
                 <a:ea typeface="Calibri" pitchFamily="34" charset="-122"/>
                 <a:cs typeface="Calibri" pitchFamily="34" charset="-120"/>
               </a:rPr>
-              <a:t>5</a:t>
-            </a:r>
-            <a:endParaRPr lang="en-US" sz="1100" dirty="0"/>
-          </a:p>
-        </p:txBody>
-      </p:sp>
-      <p:sp>
-        <p:nvSpPr>
-          <p:cNvPr id="29" name="Text 27"/>
-          <p:cNvSpPr/>
-          <p:nvPr/>
-        </p:nvSpPr>
-        <p:spPr>
-          <a:xfrm>
-            <a:off x="3749040" y="3035808"/>
-            <a:ext cx="2057400" cy="384048"/>
+              <a:t>4</a:t>
+            </a:r>
+            <a:endParaRPr lang="en-US" sz="1000" dirty="0"/>
+          </a:p>
+        </p:txBody>
+      </p:sp>
+      <p:sp>
+        <p:nvSpPr>
+          <p:cNvPr id="26" name="Text 24"/>
+          <p:cNvSpPr/>
+          <p:nvPr/>
+        </p:nvSpPr>
+        <p:spPr>
+          <a:xfrm>
+            <a:off x="3730752" y="2825496"/>
+            <a:ext cx="2084832" cy="457200"/>
           </a:xfrm>
           <a:prstGeom prst="rect">
             <a:avLst/>
@@ -3559,7 +3441,7 @@
                 <a:ea typeface="Calibri" pitchFamily="34" charset="-122"/>
                 <a:cs typeface="Calibri" pitchFamily="34" charset="-120"/>
               </a:rPr>
-              <a:t>Human oversight &amp; approval</a:t>
+              <a:t>Authorization &amp; delegation</a:t>
             </a:r>
             <a:endParaRPr lang="en-US" sz="1200" dirty="0"/>
           </a:p>
@@ -3567,14 +3449,14 @@
       </p:sp>
       <p:sp>
         <p:nvSpPr>
-          <p:cNvPr id="30" name="Shape 28"/>
-          <p:cNvSpPr/>
-          <p:nvPr/>
-        </p:nvSpPr>
-        <p:spPr>
-          <a:xfrm>
-            <a:off x="3383280" y="3593592"/>
-            <a:ext cx="274320" cy="274320"/>
+          <p:cNvPr id="27" name="Shape 25"/>
+          <p:cNvSpPr/>
+          <p:nvPr/>
+        </p:nvSpPr>
+        <p:spPr>
+          <a:xfrm>
+            <a:off x="3383280" y="3465576"/>
+            <a:ext cx="256032" cy="256032"/>
           </a:xfrm>
           <a:prstGeom prst="ellipse">
             <a:avLst/>
@@ -3592,14 +3474,14 @@
       </p:sp>
       <p:sp>
         <p:nvSpPr>
-          <p:cNvPr id="31" name="Text 29"/>
-          <p:cNvSpPr/>
-          <p:nvPr/>
-        </p:nvSpPr>
-        <p:spPr>
-          <a:xfrm>
-            <a:off x="3383280" y="3593592"/>
-            <a:ext cx="274320" cy="274320"/>
+          <p:cNvPr id="28" name="Text 26"/>
+          <p:cNvSpPr/>
+          <p:nvPr/>
+        </p:nvSpPr>
+        <p:spPr>
+          <a:xfrm>
+            <a:off x="3383280" y="3465576"/>
+            <a:ext cx="256032" cy="256032"/>
           </a:xfrm>
           <a:prstGeom prst="rect">
             <a:avLst/>
@@ -3615,7 +3497,7 @@
               <a:buNone/>
             </a:pPr>
             <a:r>
-              <a:rPr lang="en-US" sz="1100" b="1" dirty="0">
+              <a:rPr lang="en-US" sz="1000" b="1" dirty="0">
                 <a:solidFill>
                   <a:srgbClr val="FFFFFF"/>
                 </a:solidFill>
@@ -3623,22 +3505,22 @@
                 <a:ea typeface="Calibri" pitchFamily="34" charset="-122"/>
                 <a:cs typeface="Calibri" pitchFamily="34" charset="-120"/>
               </a:rPr>
-              <a:t>6</a:t>
-            </a:r>
-            <a:endParaRPr lang="en-US" sz="1100" dirty="0"/>
-          </a:p>
-        </p:txBody>
-      </p:sp>
-      <p:sp>
-        <p:nvSpPr>
-          <p:cNvPr id="32" name="Text 30"/>
-          <p:cNvSpPr/>
-          <p:nvPr/>
-        </p:nvSpPr>
-        <p:spPr>
-          <a:xfrm>
-            <a:off x="3749040" y="3557016"/>
-            <a:ext cx="2057400" cy="384048"/>
+              <a:t>9</a:t>
+            </a:r>
+            <a:endParaRPr lang="en-US" sz="1000" dirty="0"/>
+          </a:p>
+        </p:txBody>
+      </p:sp>
+      <p:sp>
+        <p:nvSpPr>
+          <p:cNvPr id="29" name="Text 27"/>
+          <p:cNvSpPr/>
+          <p:nvPr/>
+        </p:nvSpPr>
+        <p:spPr>
+          <a:xfrm>
+            <a:off x="3730752" y="3410712"/>
+            <a:ext cx="2084832" cy="457200"/>
           </a:xfrm>
           <a:prstGeom prst="rect">
             <a:avLst/>
@@ -3662,7 +3544,7 @@
                 <a:ea typeface="Calibri" pitchFamily="34" charset="-122"/>
                 <a:cs typeface="Calibri" pitchFamily="34" charset="-120"/>
               </a:rPr>
-              <a:t>Resource policy enforcement</a:t>
+              <a:t>Multi-agent collaboration</a:t>
             </a:r>
             <a:endParaRPr lang="en-US" sz="1200" dirty="0"/>
           </a:p>
@@ -3670,14 +3552,38 @@
       </p:sp>
       <p:sp>
         <p:nvSpPr>
-          <p:cNvPr id="33" name="Shape 31"/>
-          <p:cNvSpPr/>
-          <p:nvPr/>
-        </p:nvSpPr>
-        <p:spPr>
-          <a:xfrm>
-            <a:off x="6035040" y="2011680"/>
-            <a:ext cx="2743200" cy="384048"/>
+          <p:cNvPr id="30" name="Shape 28"/>
+          <p:cNvSpPr/>
+          <p:nvPr/>
+        </p:nvSpPr>
+        <p:spPr>
+          <a:xfrm>
+            <a:off x="5952744" y="1892808"/>
+            <a:ext cx="82296" cy="0"/>
+          </a:xfrm>
+          <a:prstGeom prst="line">
+            <a:avLst/>
+          </a:prstGeom>
+          <a:noFill/>
+          <a:ln w="25400">
+            <a:solidFill>
+              <a:srgbClr val="FFFFFF"/>
+            </a:solidFill>
+            <a:prstDash val="solid"/>
+            <a:tailEnd type="triangle"/>
+          </a:ln>
+        </p:spPr>
+      </p:sp>
+      <p:sp>
+        <p:nvSpPr>
+          <p:cNvPr id="31" name="Shape 29"/>
+          <p:cNvSpPr/>
+          <p:nvPr/>
+        </p:nvSpPr>
+        <p:spPr>
+          <a:xfrm>
+            <a:off x="6035040" y="1691640"/>
+            <a:ext cx="2743200" cy="411480"/>
           </a:xfrm>
           <a:prstGeom prst="rect">
             <a:avLst/>
@@ -3695,14 +3601,14 @@
       </p:sp>
       <p:sp>
         <p:nvSpPr>
-          <p:cNvPr id="34" name="Text 32"/>
-          <p:cNvSpPr/>
-          <p:nvPr/>
-        </p:nvSpPr>
-        <p:spPr>
-          <a:xfrm>
-            <a:off x="6035040" y="2011680"/>
-            <a:ext cx="2743200" cy="384048"/>
+          <p:cNvPr id="32" name="Text 30"/>
+          <p:cNvSpPr/>
+          <p:nvPr/>
+        </p:nvSpPr>
+        <p:spPr>
+          <a:xfrm>
+            <a:off x="6035040" y="1691640"/>
+            <a:ext cx="2743200" cy="411480"/>
           </a:xfrm>
           <a:prstGeom prst="rect">
             <a:avLst/>
@@ -3718,7 +3624,7 @@
               <a:buNone/>
             </a:pPr>
             <a:r>
-              <a:rPr lang="en-US" sz="1300" b="1" spc="400" kern="0" dirty="0">
+              <a:rPr lang="en-US" sz="1400" b="1" spc="500" kern="0" dirty="0">
                 <a:solidFill>
                   <a:srgbClr val="FFFFFF"/>
                 </a:solidFill>
@@ -3726,22 +3632,22 @@
                 <a:ea typeface="Calibri" pitchFamily="34" charset="-122"/>
                 <a:cs typeface="Calibri" pitchFamily="34" charset="-120"/>
               </a:rPr>
-              <a:t>LIFECYCLE</a:t>
-            </a:r>
-            <a:endParaRPr lang="en-US" sz="1300" dirty="0"/>
-          </a:p>
-        </p:txBody>
-      </p:sp>
-      <p:sp>
-        <p:nvSpPr>
-          <p:cNvPr id="35" name="Shape 33"/>
-          <p:cNvSpPr/>
-          <p:nvPr/>
-        </p:nvSpPr>
-        <p:spPr>
-          <a:xfrm>
-            <a:off x="6035040" y="2395728"/>
-            <a:ext cx="2743200" cy="2176272"/>
+              <a:t>ENFORCE</a:t>
+            </a:r>
+            <a:endParaRPr lang="en-US" sz="1400" dirty="0"/>
+          </a:p>
+        </p:txBody>
+      </p:sp>
+      <p:sp>
+        <p:nvSpPr>
+          <p:cNvPr id="33" name="Shape 31"/>
+          <p:cNvSpPr/>
+          <p:nvPr/>
+        </p:nvSpPr>
+        <p:spPr>
+          <a:xfrm>
+            <a:off x="6035040" y="2103120"/>
+            <a:ext cx="2743200" cy="2468880"/>
           </a:xfrm>
           <a:prstGeom prst="rect">
             <a:avLst/>
@@ -3759,14 +3665,14 @@
       </p:sp>
       <p:sp>
         <p:nvSpPr>
-          <p:cNvPr id="36" name="Shape 34"/>
-          <p:cNvSpPr/>
-          <p:nvPr/>
-        </p:nvSpPr>
-        <p:spPr>
-          <a:xfrm>
-            <a:off x="6217920" y="2551176"/>
-            <a:ext cx="274320" cy="274320"/>
+          <p:cNvPr id="34" name="Shape 32"/>
+          <p:cNvSpPr/>
+          <p:nvPr/>
+        </p:nvSpPr>
+        <p:spPr>
+          <a:xfrm>
+            <a:off x="6217920" y="2295144"/>
+            <a:ext cx="256032" cy="256032"/>
           </a:xfrm>
           <a:prstGeom prst="ellipse">
             <a:avLst/>
@@ -3784,14 +3690,14 @@
       </p:sp>
       <p:sp>
         <p:nvSpPr>
-          <p:cNvPr id="37" name="Text 35"/>
-          <p:cNvSpPr/>
-          <p:nvPr/>
-        </p:nvSpPr>
-        <p:spPr>
-          <a:xfrm>
-            <a:off x="6217920" y="2551176"/>
-            <a:ext cx="274320" cy="274320"/>
+          <p:cNvPr id="35" name="Text 33"/>
+          <p:cNvSpPr/>
+          <p:nvPr/>
+        </p:nvSpPr>
+        <p:spPr>
+          <a:xfrm>
+            <a:off x="6217920" y="2295144"/>
+            <a:ext cx="256032" cy="256032"/>
           </a:xfrm>
           <a:prstGeom prst="rect">
             <a:avLst/>
@@ -3807,7 +3713,7 @@
               <a:buNone/>
             </a:pPr>
             <a:r>
-              <a:rPr lang="en-US" sz="1100" b="1" dirty="0">
+              <a:rPr lang="en-US" sz="1000" b="1" dirty="0">
                 <a:solidFill>
                   <a:srgbClr val="FFFFFF"/>
                 </a:solidFill>
@@ -3815,22 +3721,22 @@
                 <a:ea typeface="Calibri" pitchFamily="34" charset="-122"/>
                 <a:cs typeface="Calibri" pitchFamily="34" charset="-120"/>
               </a:rPr>
-              <a:t>7</a:t>
-            </a:r>
-            <a:endParaRPr lang="en-US" sz="1100" dirty="0"/>
-          </a:p>
-        </p:txBody>
-      </p:sp>
-      <p:sp>
-        <p:nvSpPr>
-          <p:cNvPr id="38" name="Text 36"/>
-          <p:cNvSpPr/>
-          <p:nvPr/>
-        </p:nvSpPr>
-        <p:spPr>
-          <a:xfrm>
-            <a:off x="6583680" y="2514600"/>
-            <a:ext cx="2057400" cy="384048"/>
+              <a:t>5</a:t>
+            </a:r>
+            <a:endParaRPr lang="en-US" sz="1000" dirty="0"/>
+          </a:p>
+        </p:txBody>
+      </p:sp>
+      <p:sp>
+        <p:nvSpPr>
+          <p:cNvPr id="36" name="Text 34"/>
+          <p:cNvSpPr/>
+          <p:nvPr/>
+        </p:nvSpPr>
+        <p:spPr>
+          <a:xfrm>
+            <a:off x="6565392" y="2240280"/>
+            <a:ext cx="2084832" cy="457200"/>
           </a:xfrm>
           <a:prstGeom prst="rect">
             <a:avLst/>
@@ -3854,7 +3760,7 @@
                 <a:ea typeface="Calibri" pitchFamily="34" charset="-122"/>
                 <a:cs typeface="Calibri" pitchFamily="34" charset="-120"/>
               </a:rPr>
-              <a:t>Credential lifecycle</a:t>
+              <a:t>Human oversight &amp; approval</a:t>
             </a:r>
             <a:endParaRPr lang="en-US" sz="1200" dirty="0"/>
           </a:p>
@@ -3862,14 +3768,14 @@
       </p:sp>
       <p:sp>
         <p:nvSpPr>
-          <p:cNvPr id="39" name="Shape 37"/>
-          <p:cNvSpPr/>
-          <p:nvPr/>
-        </p:nvSpPr>
-        <p:spPr>
-          <a:xfrm>
-            <a:off x="6217920" y="3072384"/>
-            <a:ext cx="274320" cy="274320"/>
+          <p:cNvPr id="37" name="Shape 35"/>
+          <p:cNvSpPr/>
+          <p:nvPr/>
+        </p:nvSpPr>
+        <p:spPr>
+          <a:xfrm>
+            <a:off x="6217920" y="2880360"/>
+            <a:ext cx="256032" cy="256032"/>
           </a:xfrm>
           <a:prstGeom prst="ellipse">
             <a:avLst/>
@@ -3887,14 +3793,14 @@
       </p:sp>
       <p:sp>
         <p:nvSpPr>
-          <p:cNvPr id="40" name="Text 38"/>
-          <p:cNvSpPr/>
-          <p:nvPr/>
-        </p:nvSpPr>
-        <p:spPr>
-          <a:xfrm>
-            <a:off x="6217920" y="3072384"/>
-            <a:ext cx="274320" cy="274320"/>
+          <p:cNvPr id="38" name="Text 36"/>
+          <p:cNvSpPr/>
+          <p:nvPr/>
+        </p:nvSpPr>
+        <p:spPr>
+          <a:xfrm>
+            <a:off x="6217920" y="2880360"/>
+            <a:ext cx="256032" cy="256032"/>
           </a:xfrm>
           <a:prstGeom prst="rect">
             <a:avLst/>
@@ -3910,7 +3816,7 @@
               <a:buNone/>
             </a:pPr>
             <a:r>
-              <a:rPr lang="en-US" sz="1100" b="1" dirty="0">
+              <a:rPr lang="en-US" sz="1000" b="1" dirty="0">
                 <a:solidFill>
                   <a:srgbClr val="FFFFFF"/>
                 </a:solidFill>
@@ -3918,22 +3824,22 @@
                 <a:ea typeface="Calibri" pitchFamily="34" charset="-122"/>
                 <a:cs typeface="Calibri" pitchFamily="34" charset="-120"/>
               </a:rPr>
-              <a:t>8</a:t>
-            </a:r>
-            <a:endParaRPr lang="en-US" sz="1100" dirty="0"/>
-          </a:p>
-        </p:txBody>
-      </p:sp>
-      <p:sp>
-        <p:nvSpPr>
-          <p:cNvPr id="41" name="Text 39"/>
-          <p:cNvSpPr/>
-          <p:nvPr/>
-        </p:nvSpPr>
-        <p:spPr>
-          <a:xfrm>
-            <a:off x="6583680" y="3035808"/>
-            <a:ext cx="2057400" cy="384048"/>
+              <a:t>6</a:t>
+            </a:r>
+            <a:endParaRPr lang="en-US" sz="1000" dirty="0"/>
+          </a:p>
+        </p:txBody>
+      </p:sp>
+      <p:sp>
+        <p:nvSpPr>
+          <p:cNvPr id="39" name="Text 37"/>
+          <p:cNvSpPr/>
+          <p:nvPr/>
+        </p:nvSpPr>
+        <p:spPr>
+          <a:xfrm>
+            <a:off x="6565392" y="2825496"/>
+            <a:ext cx="2084832" cy="457200"/>
           </a:xfrm>
           <a:prstGeom prst="rect">
             <a:avLst/>
@@ -3957,7 +3863,7 @@
                 <a:ea typeface="Calibri" pitchFamily="34" charset="-122"/>
                 <a:cs typeface="Calibri" pitchFamily="34" charset="-120"/>
               </a:rPr>
-              <a:t>Auditability &amp; logging</a:t>
+              <a:t>Resource policy enforcement</a:t>
             </a:r>
             <a:endParaRPr lang="en-US" sz="1200" dirty="0"/>
           </a:p>
@@ -3965,14 +3871,14 @@
       </p:sp>
       <p:sp>
         <p:nvSpPr>
-          <p:cNvPr id="42" name="Shape 40"/>
-          <p:cNvSpPr/>
-          <p:nvPr/>
-        </p:nvSpPr>
-        <p:spPr>
-          <a:xfrm>
-            <a:off x="6217920" y="3593592"/>
-            <a:ext cx="274320" cy="274320"/>
+          <p:cNvPr id="40" name="Shape 38"/>
+          <p:cNvSpPr/>
+          <p:nvPr/>
+        </p:nvSpPr>
+        <p:spPr>
+          <a:xfrm>
+            <a:off x="6217920" y="3465576"/>
+            <a:ext cx="256032" cy="256032"/>
           </a:xfrm>
           <a:prstGeom prst="ellipse">
             <a:avLst/>
@@ -3990,14 +3896,14 @@
       </p:sp>
       <p:sp>
         <p:nvSpPr>
-          <p:cNvPr id="43" name="Text 41"/>
-          <p:cNvSpPr/>
-          <p:nvPr/>
-        </p:nvSpPr>
-        <p:spPr>
-          <a:xfrm>
-            <a:off x="6217920" y="3593592"/>
-            <a:ext cx="274320" cy="274320"/>
+          <p:cNvPr id="41" name="Text 39"/>
+          <p:cNvSpPr/>
+          <p:nvPr/>
+        </p:nvSpPr>
+        <p:spPr>
+          <a:xfrm>
+            <a:off x="6217920" y="3465576"/>
+            <a:ext cx="256032" cy="256032"/>
           </a:xfrm>
           <a:prstGeom prst="rect">
             <a:avLst/>
@@ -4013,7 +3919,7 @@
               <a:buNone/>
             </a:pPr>
             <a:r>
-              <a:rPr lang="en-US" sz="1100" b="1" dirty="0">
+              <a:rPr lang="en-US" sz="1000" b="1" dirty="0">
                 <a:solidFill>
                   <a:srgbClr val="FFFFFF"/>
                 </a:solidFill>
@@ -4021,11 +3927,75 @@
                 <a:ea typeface="Calibri" pitchFamily="34" charset="-122"/>
                 <a:cs typeface="Calibri" pitchFamily="34" charset="-120"/>
               </a:rPr>
-              <a:t>9</a:t>
-            </a:r>
-            <a:endParaRPr lang="en-US" sz="1100" dirty="0"/>
-          </a:p>
-        </p:txBody>
+              <a:t>7</a:t>
+            </a:r>
+            <a:endParaRPr lang="en-US" sz="1000" dirty="0"/>
+          </a:p>
+        </p:txBody>
+      </p:sp>
+      <p:sp>
+        <p:nvSpPr>
+          <p:cNvPr id="42" name="Text 40"/>
+          <p:cNvSpPr/>
+          <p:nvPr/>
+        </p:nvSpPr>
+        <p:spPr>
+          <a:xfrm>
+            <a:off x="6565392" y="3410712"/>
+            <a:ext cx="2084832" cy="457200"/>
+          </a:xfrm>
+          <a:prstGeom prst="rect">
+            <a:avLst/>
+          </a:prstGeom>
+          <a:noFill/>
+          <a:ln/>
+        </p:spPr>
+        <p:txBody>
+          <a:bodyPr wrap="square" lIns="0" tIns="0" rIns="0" bIns="0" rtlCol="0" anchor="ctr"/>
+          <a:lstStyle/>
+          <a:p>
+            <a:pPr indent="0" marL="0">
+              <a:buNone/>
+            </a:pPr>
+            <a:r>
+              <a:rPr lang="en-US" sz="1200" dirty="0">
+                <a:solidFill>
+                  <a:srgbClr val="1A1F36"/>
+                </a:solidFill>
+                <a:latin typeface="Calibri" pitchFamily="34" charset="0"/>
+                <a:ea typeface="Calibri" pitchFamily="34" charset="-122"/>
+                <a:cs typeface="Calibri" pitchFamily="34" charset="-120"/>
+              </a:rPr>
+              <a:t>Credential lifecycle</a:t>
+            </a:r>
+            <a:endParaRPr lang="en-US" sz="1200" dirty="0"/>
+          </a:p>
+        </p:txBody>
+      </p:sp>
+      <p:sp>
+        <p:nvSpPr>
+          <p:cNvPr id="43" name="Shape 41"/>
+          <p:cNvSpPr/>
+          <p:nvPr/>
+        </p:nvSpPr>
+        <p:spPr>
+          <a:xfrm>
+            <a:off x="6217920" y="4050792"/>
+            <a:ext cx="256032" cy="256032"/>
+          </a:xfrm>
+          <a:prstGeom prst="ellipse">
+            <a:avLst/>
+          </a:prstGeom>
+          <a:solidFill>
+            <a:srgbClr val="7C3AED"/>
+          </a:solidFill>
+          <a:ln w="12700">
+            <a:solidFill>
+              <a:srgbClr val="7C3AED"/>
+            </a:solidFill>
+            <a:prstDash val="solid"/>
+          </a:ln>
+        </p:spPr>
       </p:sp>
       <p:sp>
         <p:nvSpPr>
@@ -4035,8 +4005,47 @@
         </p:nvSpPr>
         <p:spPr>
           <a:xfrm>
-            <a:off x="6583680" y="3557016"/>
-            <a:ext cx="2057400" cy="384048"/>
+            <a:off x="6217920" y="4050792"/>
+            <a:ext cx="256032" cy="256032"/>
+          </a:xfrm>
+          <a:prstGeom prst="rect">
+            <a:avLst/>
+          </a:prstGeom>
+          <a:noFill/>
+          <a:ln/>
+        </p:spPr>
+        <p:txBody>
+          <a:bodyPr wrap="square" lIns="0" tIns="0" rIns="0" bIns="0" rtlCol="0" anchor="ctr"/>
+          <a:lstStyle/>
+          <a:p>
+            <a:pPr algn="ctr" indent="0" marL="0">
+              <a:buNone/>
+            </a:pPr>
+            <a:r>
+              <a:rPr lang="en-US" sz="1000" b="1" dirty="0">
+                <a:solidFill>
+                  <a:srgbClr val="FFFFFF"/>
+                </a:solidFill>
+                <a:latin typeface="Calibri" pitchFamily="34" charset="0"/>
+                <a:ea typeface="Calibri" pitchFamily="34" charset="-122"/>
+                <a:cs typeface="Calibri" pitchFamily="34" charset="-120"/>
+              </a:rPr>
+              <a:t>8</a:t>
+            </a:r>
+            <a:endParaRPr lang="en-US" sz="1000" dirty="0"/>
+          </a:p>
+        </p:txBody>
+      </p:sp>
+      <p:sp>
+        <p:nvSpPr>
+          <p:cNvPr id="45" name="Text 43"/>
+          <p:cNvSpPr/>
+          <p:nvPr/>
+        </p:nvSpPr>
+        <p:spPr>
+          <a:xfrm>
+            <a:off x="6565392" y="3995928"/>
+            <a:ext cx="2084832" cy="457200"/>
           </a:xfrm>
           <a:prstGeom prst="rect">
             <a:avLst/>
@@ -4060,7 +4069,7 @@
                 <a:ea typeface="Calibri" pitchFamily="34" charset="-122"/>
                 <a:cs typeface="Calibri" pitchFamily="34" charset="-120"/>
               </a:rPr>
-              <a:t>Multi-agent collaboration</a:t>
+              <a:t>Auditability &amp; logging</a:t>
             </a:r>
             <a:endParaRPr lang="en-US" sz="1200" dirty="0"/>
           </a:p>
@@ -4068,30 +4077,30 @@
       </p:sp>
       <p:sp>
         <p:nvSpPr>
-          <p:cNvPr id="45" name="Text 43"/>
-          <p:cNvSpPr/>
-          <p:nvPr/>
-        </p:nvSpPr>
-        <p:spPr>
-          <a:xfrm>
-            <a:off x="457200" y="4617720"/>
-            <a:ext cx="8229600" cy="320040"/>
-          </a:xfrm>
-          <a:prstGeom prst="rect">
-            <a:avLst/>
-          </a:prstGeom>
-          <a:noFill/>
-          <a:ln/>
-        </p:spPr>
-        <p:txBody>
-          <a:bodyPr wrap="square" lIns="0" tIns="0" rIns="0" bIns="0" rtlCol="0" anchor="ctr"/>
-          <a:lstStyle/>
-          <a:p>
-            <a:pPr algn="ctr" indent="0" marL="0">
-              <a:buNone/>
-            </a:pPr>
-            <a:r>
-              <a:rPr lang="en-US" sz="1100" i="1" dirty="0">
+          <p:cNvPr id="46" name="Text 44"/>
+          <p:cNvSpPr/>
+          <p:nvPr/>
+        </p:nvSpPr>
+        <p:spPr>
+          <a:xfrm>
+            <a:off x="457200" y="4663440"/>
+            <a:ext cx="8229600" cy="256032"/>
+          </a:xfrm>
+          <a:prstGeom prst="rect">
+            <a:avLst/>
+          </a:prstGeom>
+          <a:noFill/>
+          <a:ln/>
+        </p:spPr>
+        <p:txBody>
+          <a:bodyPr wrap="square" lIns="0" tIns="0" rIns="0" bIns="0" rtlCol="0" anchor="ctr"/>
+          <a:lstStyle/>
+          <a:p>
+            <a:pPr indent="0" marL="0">
+              <a:buNone/>
+            </a:pPr>
+            <a:r>
+              <a:rPr lang="en-US" sz="1000" i="1" dirty="0">
                 <a:solidFill>
                   <a:srgbClr val="64748B"/>
                 </a:solidFill>
@@ -4099,15 +4108,15 @@
                 <a:ea typeface="Calibri" pitchFamily="34" charset="-122"/>
                 <a:cs typeface="Calibri" pitchFamily="34" charset="-120"/>
               </a:rPr>
-              <a:t>P0 covers the full Visibility group + Authorization + Resource policy + Auditability. Everything else is post-P0.</a:t>
-            </a:r>
-            <a:endParaRPr lang="en-US" sz="1100" dirty="0"/>
-          </a:p>
-        </p:txBody>
-      </p:sp>
-      <p:sp>
-        <p:nvSpPr>
-          <p:cNvPr id="46" name="Text 44"/>
+              <a:t>Source: “IAM for LLM-Based AI Agents” framework.</a:t>
+            </a:r>
+            <a:endParaRPr lang="en-US" sz="1000" dirty="0"/>
+          </a:p>
+        </p:txBody>
+      </p:sp>
+      <p:sp>
+        <p:nvSpPr>
+          <p:cNvPr id="47" name="Text 45"/>
           <p:cNvSpPr/>
           <p:nvPr/>
         </p:nvSpPr>

</xml_diff>

<commit_message>
Deck v8: name owners, Wednesday sync, sharpen why-now
- Gateway Core card: Javier + Omer Blechman as owners, M1/M2 feeds = part of discovery
- Outcome B: owners named, first sync Wednesday (deadline from room)
- Why-now footer: agents = fastest-growing identity category, one-stop shop framing

Co-Authored-By: Claude Sonnet 4.6 <noreply@anthropic.com>
</commit_message>
<xml_diff>
--- a/artifacts/eng-prekickoff-2026-04-27.pptx
+++ b/artifacts/eng-prekickoff-2026-04-27.pptx
@@ -3216,7 +3216,7 @@
                 <a:ea typeface="Calibri" pitchFamily="34" charset="-122"/>
                 <a:cs typeface="Calibri" pitchFamily="34" charset="-120"/>
               </a:rPr>
-              <a:t>Race is on: Saviynt, Token Security, Astrix all moving on MCP-layer governance. No customer has asked by name — yet.</a:t>
+              <a:t>Agents are the fastest-growing identity category. We want to be the one-stop shop — this is the moment. Race is on: Saviynt, Token Security, Astrix all converging here.</a:t>
             </a:r>
             <a:endParaRPr lang="en-US" sz="1000" dirty="0"/>
           </a:p>
@@ -3596,7 +3596,7 @@
                 <a:ea typeface="Calibri" pitchFamily="34" charset="-122"/>
                 <a:cs typeface="Calibri" pitchFamily="34" charset="-120"/>
               </a:rPr>
-              <a:t>Eng research starts here</a:t>
+              <a:t>Javier + Omer Blechman · research starts here · what feeds in from M1/M2 = part of this discovery</a:t>
             </a:r>
             <a:endParaRPr lang="en-US" sz="900" dirty="0"/>
           </a:p>
@@ -5047,7 +5047,7 @@
                 <a:ea typeface="Georgia" pitchFamily="34" charset="-122"/>
                 <a:cs typeface="Georgia" pitchFamily="34" charset="-120"/>
               </a:rPr>
-              <a:t>Eng owns Gateway Core POC</a:t>
+              <a:t>Gateway Core POC plan</a:t>
             </a:r>
             <a:endParaRPr lang="en-US" sz="1400" dirty="0"/>
           </a:p>
@@ -5115,7 +5115,7 @@
                 <a:ea typeface="Calibri" pitchFamily="34" charset="-122"/>
                 <a:cs typeface="Calibri" pitchFamily="34" charset="-120"/>
               </a:rPr>
-              <a:t>Options mapped: build vs. adopt</a:t>
+              <a:t>Owners: Javier + Omer Blechman</a:t>
             </a:r>
             <a:endParaRPr lang="en-US" sz="1100" dirty="0"/>
           </a:p>
@@ -5136,7 +5136,7 @@
                 <a:ea typeface="Calibri" pitchFamily="34" charset="-122"/>
                 <a:cs typeface="Calibri" pitchFamily="34" charset="-120"/>
               </a:rPr>
-              <a:t>Coverage trade-offs understood</a:t>
+              <a:t>Options mapped: build vs. adopt</a:t>
             </a:r>
             <a:endParaRPr lang="en-US" sz="1100" dirty="0"/>
           </a:p>
@@ -5157,28 +5157,27 @@
                 <a:ea typeface="Calibri" pitchFamily="34" charset="-122"/>
                 <a:cs typeface="Calibri" pitchFamily="34" charset="-120"/>
               </a:rPr>
-              <a:t>Checkpoint date set (2 weeks out)</a:t>
+              <a:t>What from M1/M2 feeds in</a:t>
             </a:r>
             <a:endParaRPr lang="en-US" sz="1100" dirty="0"/>
           </a:p>
           <a:p>
-            <a:pPr marL="342900" indent="-342900">
+            <a:pPr indent="0" marL="0">
               <a:spcAft>
                 <a:spcPts val="500"/>
               </a:spcAft>
-              <a:buSzPct val="100000"/>
-              <a:buChar char="■"/>
-            </a:pPr>
-            <a:r>
-              <a:rPr lang="en-US" sz="1100" dirty="0">
-                <a:solidFill>
-                  <a:srgbClr val="FFFFFF"/>
-                </a:solidFill>
-                <a:latin typeface="Calibri" pitchFamily="34" charset="0"/>
-                <a:ea typeface="Calibri" pitchFamily="34" charset="-122"/>
-                <a:cs typeface="Calibri" pitchFamily="34" charset="-120"/>
-              </a:rPr>
-              <a:t>Owner named</a:t>
+              <a:buNone/>
+            </a:pPr>
+            <a:r>
+              <a:rPr lang="en-US" sz="1100" b="1" dirty="0">
+                <a:solidFill>
+                  <a:srgbClr val="F59E0B"/>
+                </a:solidFill>
+                <a:latin typeface="Calibri" pitchFamily="34" charset="0"/>
+                <a:ea typeface="Calibri" pitchFamily="34" charset="-122"/>
+                <a:cs typeface="Calibri" pitchFamily="34" charset="-120"/>
+              </a:rPr>
+              <a:t>→ First sync: Wednesday</a:t>
             </a:r>
             <a:endParaRPr lang="en-US" sz="1100" dirty="0"/>
           </a:p>

</xml_diff>

<commit_message>
Deck v9: demo options, timeline, column flip, stronger why-now
- Outcome C: pre-load 3 demo format options (thin live / wide canned / hybrid)
- Outcome B: directional timeline Apr 27 → May 11 → Jun 1 → Jun 15
- Slide 3: flip columns — what we've built left, gap right
- Pivot footer: explicit consequence — if Saviynt defines MCP governance at Identiverse, category is theirs

Co-Authored-By: Claude Sonnet 4.6 <noreply@anthropic.com>
</commit_message>
<xml_diff>
--- a/artifacts/eng-prekickoff-2026-04-27.pptx
+++ b/artifacts/eng-prekickoff-2026-04-27.pptx
@@ -1691,6 +1691,407 @@
         <p:spPr>
           <a:xfrm>
             <a:off x="457200" y="1554480"/>
+            <a:ext cx="3931920" cy="2560320"/>
+          </a:xfrm>
+          <a:prstGeom prst="rect">
+            <a:avLst/>
+          </a:prstGeom>
+          <a:solidFill>
+            <a:srgbClr val="0F1B3D"/>
+          </a:solidFill>
+          <a:ln w="12700">
+            <a:solidFill>
+              <a:srgbClr val="0F1B3D"/>
+            </a:solidFill>
+            <a:prstDash val="solid"/>
+          </a:ln>
+        </p:spPr>
+      </p:sp>
+      <p:sp>
+        <p:nvSpPr>
+          <p:cNvPr id="6" name="Shape 4"/>
+          <p:cNvSpPr/>
+          <p:nvPr/>
+        </p:nvSpPr>
+        <p:spPr>
+          <a:xfrm>
+            <a:off x="457200" y="1554480"/>
+            <a:ext cx="73152" cy="2560320"/>
+          </a:xfrm>
+          <a:prstGeom prst="rect">
+            <a:avLst/>
+          </a:prstGeom>
+          <a:solidFill>
+            <a:srgbClr val="02C39A"/>
+          </a:solidFill>
+          <a:ln w="12700">
+            <a:solidFill>
+              <a:srgbClr val="02C39A"/>
+            </a:solidFill>
+            <a:prstDash val="solid"/>
+          </a:ln>
+        </p:spPr>
+      </p:sp>
+      <p:sp>
+        <p:nvSpPr>
+          <p:cNvPr id="7" name="Text 5"/>
+          <p:cNvSpPr/>
+          <p:nvPr/>
+        </p:nvSpPr>
+        <p:spPr>
+          <a:xfrm>
+            <a:off x="685800" y="1664208"/>
+            <a:ext cx="3474720" cy="256032"/>
+          </a:xfrm>
+          <a:prstGeom prst="rect">
+            <a:avLst/>
+          </a:prstGeom>
+          <a:noFill/>
+          <a:ln/>
+        </p:spPr>
+        <p:txBody>
+          <a:bodyPr wrap="square" lIns="0" tIns="0" rIns="0" bIns="0" rtlCol="0" anchor="ctr"/>
+          <a:lstStyle/>
+          <a:p>
+            <a:pPr indent="0" marL="0">
+              <a:buNone/>
+            </a:pPr>
+            <a:r>
+              <a:rPr lang="en-US" sz="1000" b="1" spc="300" kern="0" dirty="0">
+                <a:solidFill>
+                  <a:srgbClr val="02C39A"/>
+                </a:solidFill>
+                <a:latin typeface="Calibri" pitchFamily="34" charset="0"/>
+                <a:ea typeface="Calibri" pitchFamily="34" charset="-122"/>
+                <a:cs typeface="Calibri" pitchFamily="34" charset="-120"/>
+              </a:rPr>
+              <a:t>WHAT WE'VE BUILT</a:t>
+            </a:r>
+            <a:endParaRPr lang="en-US" sz="1000" dirty="0"/>
+          </a:p>
+        </p:txBody>
+      </p:sp>
+      <p:sp>
+        <p:nvSpPr>
+          <p:cNvPr id="8" name="Shape 6"/>
+          <p:cNvSpPr/>
+          <p:nvPr/>
+        </p:nvSpPr>
+        <p:spPr>
+          <a:xfrm>
+            <a:off x="713232" y="2075688"/>
+            <a:ext cx="201168" cy="201168"/>
+          </a:xfrm>
+          <a:prstGeom prst="ellipse">
+            <a:avLst/>
+          </a:prstGeom>
+          <a:solidFill>
+            <a:srgbClr val="02C39A"/>
+          </a:solidFill>
+          <a:ln w="12700">
+            <a:solidFill>
+              <a:srgbClr val="02C39A"/>
+            </a:solidFill>
+            <a:prstDash val="solid"/>
+          </a:ln>
+        </p:spPr>
+      </p:sp>
+      <p:sp>
+        <p:nvSpPr>
+          <p:cNvPr id="9" name="Text 7"/>
+          <p:cNvSpPr/>
+          <p:nvPr/>
+        </p:nvSpPr>
+        <p:spPr>
+          <a:xfrm>
+            <a:off x="1005840" y="2011680"/>
+            <a:ext cx="3200400" cy="457200"/>
+          </a:xfrm>
+          <a:prstGeom prst="rect">
+            <a:avLst/>
+          </a:prstGeom>
+          <a:noFill/>
+          <a:ln/>
+        </p:spPr>
+        <p:txBody>
+          <a:bodyPr wrap="square" lIns="0" tIns="0" rIns="0" bIns="0" rtlCol="0" anchor="ctr"/>
+          <a:lstStyle/>
+          <a:p>
+            <a:pPr indent="0" marL="0">
+              <a:buNone/>
+            </a:pPr>
+            <a:r>
+              <a:rPr lang="en-US" sz="1200" b="1" dirty="0">
+                <a:solidFill>
+                  <a:srgbClr val="FFFFFF"/>
+                </a:solidFill>
+                <a:latin typeface="Calibri" pitchFamily="34" charset="0"/>
+                <a:ea typeface="Calibri" pitchFamily="34" charset="-122"/>
+                <a:cs typeface="Calibri" pitchFamily="34" charset="-120"/>
+              </a:rPr>
+              <a:t>Agent graph model  </a:t>
+            </a:r>
+            <a:pPr indent="0" marL="0">
+              <a:buNone/>
+            </a:pPr>
+            <a:r>
+              <a:rPr lang="en-US" sz="1100" dirty="0">
+                <a:solidFill>
+                  <a:srgbClr val="E8EEFC"/>
+                </a:solidFill>
+                <a:latin typeface="Calibri" pitchFamily="34" charset="0"/>
+                <a:ea typeface="Calibri" pitchFamily="34" charset="-122"/>
+                <a:cs typeface="Calibri" pitchFamily="34" charset="-120"/>
+              </a:rPr>
+              <a:t>First-class entity</a:t>
+            </a:r>
+            <a:endParaRPr lang="en-US" sz="1200" dirty="0"/>
+          </a:p>
+        </p:txBody>
+      </p:sp>
+      <p:sp>
+        <p:nvSpPr>
+          <p:cNvPr id="10" name="Shape 8"/>
+          <p:cNvSpPr/>
+          <p:nvPr/>
+        </p:nvSpPr>
+        <p:spPr>
+          <a:xfrm>
+            <a:off x="713232" y="2578608"/>
+            <a:ext cx="201168" cy="201168"/>
+          </a:xfrm>
+          <a:prstGeom prst="ellipse">
+            <a:avLst/>
+          </a:prstGeom>
+          <a:solidFill>
+            <a:srgbClr val="02C39A"/>
+          </a:solidFill>
+          <a:ln w="12700">
+            <a:solidFill>
+              <a:srgbClr val="02C39A"/>
+            </a:solidFill>
+            <a:prstDash val="solid"/>
+          </a:ln>
+        </p:spPr>
+      </p:sp>
+      <p:sp>
+        <p:nvSpPr>
+          <p:cNvPr id="11" name="Text 9"/>
+          <p:cNvSpPr/>
+          <p:nvPr/>
+        </p:nvSpPr>
+        <p:spPr>
+          <a:xfrm>
+            <a:off x="1005840" y="2514600"/>
+            <a:ext cx="3200400" cy="457200"/>
+          </a:xfrm>
+          <a:prstGeom prst="rect">
+            <a:avLst/>
+          </a:prstGeom>
+          <a:noFill/>
+          <a:ln/>
+        </p:spPr>
+        <p:txBody>
+          <a:bodyPr wrap="square" lIns="0" tIns="0" rIns="0" bIns="0" rtlCol="0" anchor="ctr"/>
+          <a:lstStyle/>
+          <a:p>
+            <a:pPr indent="0" marL="0">
+              <a:buNone/>
+            </a:pPr>
+            <a:r>
+              <a:rPr lang="en-US" sz="1200" b="1" dirty="0">
+                <a:solidFill>
+                  <a:srgbClr val="FFFFFF"/>
+                </a:solidFill>
+                <a:latin typeface="Calibri" pitchFamily="34" charset="0"/>
+                <a:ea typeface="Calibri" pitchFamily="34" charset="-122"/>
+                <a:cs typeface="Calibri" pitchFamily="34" charset="-120"/>
+              </a:rPr>
+              <a:t>Discovery &gt; Agents UI  </a:t>
+            </a:r>
+            <a:pPr indent="0" marL="0">
+              <a:buNone/>
+            </a:pPr>
+            <a:r>
+              <a:rPr lang="en-US" sz="1100" dirty="0">
+                <a:solidFill>
+                  <a:srgbClr val="E8EEFC"/>
+                </a:solidFill>
+                <a:latin typeface="Calibri" pitchFamily="34" charset="0"/>
+                <a:ea typeface="Calibri" pitchFamily="34" charset="-122"/>
+                <a:cs typeface="Calibri" pitchFamily="34" charset="-120"/>
+              </a:rPr>
+              <a:t>Live data</a:t>
+            </a:r>
+            <a:endParaRPr lang="en-US" sz="1200" dirty="0"/>
+          </a:p>
+        </p:txBody>
+      </p:sp>
+      <p:sp>
+        <p:nvSpPr>
+          <p:cNvPr id="12" name="Shape 10"/>
+          <p:cNvSpPr/>
+          <p:nvPr/>
+        </p:nvSpPr>
+        <p:spPr>
+          <a:xfrm>
+            <a:off x="713232" y="3081528"/>
+            <a:ext cx="201168" cy="201168"/>
+          </a:xfrm>
+          <a:prstGeom prst="ellipse">
+            <a:avLst/>
+          </a:prstGeom>
+          <a:solidFill>
+            <a:srgbClr val="02C39A"/>
+          </a:solidFill>
+          <a:ln w="12700">
+            <a:solidFill>
+              <a:srgbClr val="02C39A"/>
+            </a:solidFill>
+            <a:prstDash val="solid"/>
+          </a:ln>
+        </p:spPr>
+      </p:sp>
+      <p:sp>
+        <p:nvSpPr>
+          <p:cNvPr id="13" name="Text 11"/>
+          <p:cNvSpPr/>
+          <p:nvPr/>
+        </p:nvSpPr>
+        <p:spPr>
+          <a:xfrm>
+            <a:off x="1005840" y="3017520"/>
+            <a:ext cx="3200400" cy="457200"/>
+          </a:xfrm>
+          <a:prstGeom prst="rect">
+            <a:avLst/>
+          </a:prstGeom>
+          <a:noFill/>
+          <a:ln/>
+        </p:spPr>
+        <p:txBody>
+          <a:bodyPr wrap="square" lIns="0" tIns="0" rIns="0" bIns="0" rtlCol="0" anchor="ctr"/>
+          <a:lstStyle/>
+          <a:p>
+            <a:pPr indent="0" marL="0">
+              <a:buNone/>
+            </a:pPr>
+            <a:r>
+              <a:rPr lang="en-US" sz="1200" b="1" dirty="0">
+                <a:solidFill>
+                  <a:srgbClr val="FFFFFF"/>
+                </a:solidFill>
+                <a:latin typeface="Calibri" pitchFamily="34" charset="0"/>
+                <a:ea typeface="Calibri" pitchFamily="34" charset="-122"/>
+                <a:cs typeface="Calibri" pitchFamily="34" charset="-120"/>
+              </a:rPr>
+              <a:t>Connectors  </a:t>
+            </a:r>
+            <a:pPr indent="0" marL="0">
+              <a:buNone/>
+            </a:pPr>
+            <a:r>
+              <a:rPr lang="en-US" sz="1100" dirty="0">
+                <a:solidFill>
+                  <a:srgbClr val="E8EEFC"/>
+                </a:solidFill>
+                <a:latin typeface="Calibri" pitchFamily="34" charset="0"/>
+                <a:ea typeface="Calibri" pitchFamily="34" charset="-122"/>
+                <a:cs typeface="Calibri" pitchFamily="34" charset="-120"/>
+              </a:rPr>
+              <a:t>Gemini · Vertex AI · Bedrock · n8n</a:t>
+            </a:r>
+            <a:endParaRPr lang="en-US" sz="1200" dirty="0"/>
+          </a:p>
+        </p:txBody>
+      </p:sp>
+      <p:sp>
+        <p:nvSpPr>
+          <p:cNvPr id="14" name="Shape 12"/>
+          <p:cNvSpPr/>
+          <p:nvPr/>
+        </p:nvSpPr>
+        <p:spPr>
+          <a:xfrm>
+            <a:off x="713232" y="3584448"/>
+            <a:ext cx="201168" cy="201168"/>
+          </a:xfrm>
+          <a:prstGeom prst="ellipse">
+            <a:avLst/>
+          </a:prstGeom>
+          <a:solidFill>
+            <a:srgbClr val="02C39A"/>
+          </a:solidFill>
+          <a:ln w="12700">
+            <a:solidFill>
+              <a:srgbClr val="02C39A"/>
+            </a:solidFill>
+            <a:prstDash val="solid"/>
+          </a:ln>
+        </p:spPr>
+      </p:sp>
+      <p:sp>
+        <p:nvSpPr>
+          <p:cNvPr id="15" name="Text 13"/>
+          <p:cNvSpPr/>
+          <p:nvPr/>
+        </p:nvSpPr>
+        <p:spPr>
+          <a:xfrm>
+            <a:off x="1005840" y="3520440"/>
+            <a:ext cx="3200400" cy="457200"/>
+          </a:xfrm>
+          <a:prstGeom prst="rect">
+            <a:avLst/>
+          </a:prstGeom>
+          <a:noFill/>
+          <a:ln/>
+        </p:spPr>
+        <p:txBody>
+          <a:bodyPr wrap="square" lIns="0" tIns="0" rIns="0" bIns="0" rtlCol="0" anchor="ctr"/>
+          <a:lstStyle/>
+          <a:p>
+            <a:pPr indent="0" marL="0">
+              <a:buNone/>
+            </a:pPr>
+            <a:r>
+              <a:rPr lang="en-US" sz="1200" b="1" dirty="0">
+                <a:solidFill>
+                  <a:srgbClr val="FFFFFF"/>
+                </a:solidFill>
+                <a:latin typeface="Calibri" pitchFamily="34" charset="0"/>
+                <a:ea typeface="Calibri" pitchFamily="34" charset="-122"/>
+                <a:cs typeface="Calibri" pitchFamily="34" charset="-120"/>
+              </a:rPr>
+              <a:t>Built-in issues  </a:t>
+            </a:r>
+            <a:pPr indent="0" marL="0">
+              <a:buNone/>
+            </a:pPr>
+            <a:r>
+              <a:rPr lang="en-US" sz="1100" dirty="0">
+                <a:solidFill>
+                  <a:srgbClr val="E8EEFC"/>
+                </a:solidFill>
+                <a:latin typeface="Calibri" pitchFamily="34" charset="0"/>
+                <a:ea typeface="Calibri" pitchFamily="34" charset="-122"/>
+                <a:cs typeface="Calibri" pitchFamily="34" charset="-120"/>
+              </a:rPr>
+              <a:t>AGENT_EXCESSIVE_PERMISSIONS, AGENT_OWNER_OFFBOARDED</a:t>
+            </a:r>
+            <a:endParaRPr lang="en-US" sz="1200" dirty="0"/>
+          </a:p>
+        </p:txBody>
+      </p:sp>
+      <p:sp>
+        <p:nvSpPr>
+          <p:cNvPr id="16" name="Shape 14"/>
+          <p:cNvSpPr/>
+          <p:nvPr/>
+        </p:nvSpPr>
+        <p:spPr>
+          <a:xfrm>
+            <a:off x="4572000" y="1554480"/>
             <a:ext cx="4114800" cy="2560320"/>
           </a:xfrm>
           <a:prstGeom prst="rect">
@@ -1709,13 +2110,13 @@
       </p:sp>
       <p:sp>
         <p:nvSpPr>
-          <p:cNvPr id="6" name="Shape 4"/>
-          <p:cNvSpPr/>
-          <p:nvPr/>
-        </p:nvSpPr>
-        <p:spPr>
-          <a:xfrm>
-            <a:off x="457200" y="1554480"/>
+          <p:cNvPr id="17" name="Shape 15"/>
+          <p:cNvSpPr/>
+          <p:nvPr/>
+        </p:nvSpPr>
+        <p:spPr>
+          <a:xfrm>
+            <a:off x="4572000" y="1554480"/>
             <a:ext cx="73152" cy="2560320"/>
           </a:xfrm>
           <a:prstGeom prst="rect">
@@ -1734,13 +2135,13 @@
       </p:sp>
       <p:sp>
         <p:nvSpPr>
-          <p:cNvPr id="7" name="Text 5"/>
-          <p:cNvSpPr/>
-          <p:nvPr/>
-        </p:nvSpPr>
-        <p:spPr>
-          <a:xfrm>
-            <a:off x="685800" y="1664208"/>
+          <p:cNvPr id="18" name="Text 16"/>
+          <p:cNvSpPr/>
+          <p:nvPr/>
+        </p:nvSpPr>
+        <p:spPr>
+          <a:xfrm>
+            <a:off x="4800600" y="1664208"/>
             <a:ext cx="3657600" cy="256032"/>
           </a:xfrm>
           <a:prstGeom prst="rect">
@@ -1765,7 +2166,7 @@
                 <a:ea typeface="Calibri" pitchFamily="34" charset="-122"/>
                 <a:cs typeface="Calibri" pitchFamily="34" charset="-120"/>
               </a:rPr>
-              <a:t>THE PROBLEM</a:t>
+              <a:t>THE GAP</a:t>
             </a:r>
             <a:endParaRPr lang="en-US" sz="1000" dirty="0"/>
           </a:p>
@@ -1773,13 +2174,13 @@
       </p:sp>
       <p:sp>
         <p:nvSpPr>
-          <p:cNvPr id="8" name="Text 6"/>
-          <p:cNvSpPr/>
-          <p:nvPr/>
-        </p:nvSpPr>
-        <p:spPr>
-          <a:xfrm>
-            <a:off x="685800" y="1993392"/>
+          <p:cNvPr id="19" name="Text 17"/>
+          <p:cNvSpPr/>
+          <p:nvPr/>
+        </p:nvSpPr>
+        <p:spPr>
+          <a:xfrm>
+            <a:off x="4800600" y="1993392"/>
             <a:ext cx="3657600" cy="1920240"/>
           </a:xfrm>
           <a:prstGeom prst="rect">
@@ -1804,7 +2205,7 @@
                 <a:ea typeface="Calibri" pitchFamily="34" charset="-122"/>
                 <a:cs typeface="Calibri" pitchFamily="34" charset="-120"/>
               </a:rPr>
-              <a:t>Enterprises now run more agents than humans — 144 : 1.</a:t>
+              <a:t>144 : 1 — more agents than humans in the average enterprise.</a:t>
             </a:r>
             <a:endParaRPr lang="en-US" sz="1300" dirty="0"/>
           </a:p>
@@ -1838,7 +2239,7 @@
                 <a:ea typeface="Calibri" pitchFamily="34" charset="-122"/>
                 <a:cs typeface="Calibri" pitchFamily="34" charset="-120"/>
               </a:rPr>
-              <a:t>Existing IAM and PAM tools were built for humans and NHIs. They don't govern agents that spin up in seconds, chain through tools, and decide at runtime.</a:t>
+              <a:t>IAM and PAM tools were built for humans and NHIs. They don't govern agents that spin up in seconds, chain through tools, and decide at runtime.</a:t>
             </a:r>
             <a:endParaRPr lang="en-US" sz="1300" dirty="0"/>
           </a:p>
@@ -1875,407 +2276,6 @@
               <a:t>No visibility. No policy. No audit trail.</a:t>
             </a:r>
             <a:endParaRPr lang="en-US" sz="1300" dirty="0"/>
-          </a:p>
-        </p:txBody>
-      </p:sp>
-      <p:sp>
-        <p:nvSpPr>
-          <p:cNvPr id="9" name="Shape 7"/>
-          <p:cNvSpPr/>
-          <p:nvPr/>
-        </p:nvSpPr>
-        <p:spPr>
-          <a:xfrm>
-            <a:off x="4754880" y="1554480"/>
-            <a:ext cx="3931920" cy="2560320"/>
-          </a:xfrm>
-          <a:prstGeom prst="rect">
-            <a:avLst/>
-          </a:prstGeom>
-          <a:solidFill>
-            <a:srgbClr val="0F1B3D"/>
-          </a:solidFill>
-          <a:ln w="12700">
-            <a:solidFill>
-              <a:srgbClr val="0F1B3D"/>
-            </a:solidFill>
-            <a:prstDash val="solid"/>
-          </a:ln>
-        </p:spPr>
-      </p:sp>
-      <p:sp>
-        <p:nvSpPr>
-          <p:cNvPr id="10" name="Shape 8"/>
-          <p:cNvSpPr/>
-          <p:nvPr/>
-        </p:nvSpPr>
-        <p:spPr>
-          <a:xfrm>
-            <a:off x="4754880" y="1554480"/>
-            <a:ext cx="73152" cy="2560320"/>
-          </a:xfrm>
-          <a:prstGeom prst="rect">
-            <a:avLst/>
-          </a:prstGeom>
-          <a:solidFill>
-            <a:srgbClr val="02C39A"/>
-          </a:solidFill>
-          <a:ln w="12700">
-            <a:solidFill>
-              <a:srgbClr val="02C39A"/>
-            </a:solidFill>
-            <a:prstDash val="solid"/>
-          </a:ln>
-        </p:spPr>
-      </p:sp>
-      <p:sp>
-        <p:nvSpPr>
-          <p:cNvPr id="11" name="Text 9"/>
-          <p:cNvSpPr/>
-          <p:nvPr/>
-        </p:nvSpPr>
-        <p:spPr>
-          <a:xfrm>
-            <a:off x="4983480" y="1664208"/>
-            <a:ext cx="3474720" cy="256032"/>
-          </a:xfrm>
-          <a:prstGeom prst="rect">
-            <a:avLst/>
-          </a:prstGeom>
-          <a:noFill/>
-          <a:ln/>
-        </p:spPr>
-        <p:txBody>
-          <a:bodyPr wrap="square" lIns="0" tIns="0" rIns="0" bIns="0" rtlCol="0" anchor="ctr"/>
-          <a:lstStyle/>
-          <a:p>
-            <a:pPr indent="0" marL="0">
-              <a:buNone/>
-            </a:pPr>
-            <a:r>
-              <a:rPr lang="en-US" sz="1000" b="1" spc="300" kern="0" dirty="0">
-                <a:solidFill>
-                  <a:srgbClr val="02C39A"/>
-                </a:solidFill>
-                <a:latin typeface="Calibri" pitchFamily="34" charset="0"/>
-                <a:ea typeface="Calibri" pitchFamily="34" charset="-122"/>
-                <a:cs typeface="Calibri" pitchFamily="34" charset="-120"/>
-              </a:rPr>
-              <a:t>WHAT WE'VE BUILT</a:t>
-            </a:r>
-            <a:endParaRPr lang="en-US" sz="1000" dirty="0"/>
-          </a:p>
-        </p:txBody>
-      </p:sp>
-      <p:sp>
-        <p:nvSpPr>
-          <p:cNvPr id="12" name="Shape 10"/>
-          <p:cNvSpPr/>
-          <p:nvPr/>
-        </p:nvSpPr>
-        <p:spPr>
-          <a:xfrm>
-            <a:off x="5010912" y="2075688"/>
-            <a:ext cx="201168" cy="201168"/>
-          </a:xfrm>
-          <a:prstGeom prst="ellipse">
-            <a:avLst/>
-          </a:prstGeom>
-          <a:solidFill>
-            <a:srgbClr val="02C39A"/>
-          </a:solidFill>
-          <a:ln w="12700">
-            <a:solidFill>
-              <a:srgbClr val="02C39A"/>
-            </a:solidFill>
-            <a:prstDash val="solid"/>
-          </a:ln>
-        </p:spPr>
-      </p:sp>
-      <p:sp>
-        <p:nvSpPr>
-          <p:cNvPr id="13" name="Text 11"/>
-          <p:cNvSpPr/>
-          <p:nvPr/>
-        </p:nvSpPr>
-        <p:spPr>
-          <a:xfrm>
-            <a:off x="5303520" y="2011680"/>
-            <a:ext cx="3200400" cy="457200"/>
-          </a:xfrm>
-          <a:prstGeom prst="rect">
-            <a:avLst/>
-          </a:prstGeom>
-          <a:noFill/>
-          <a:ln/>
-        </p:spPr>
-        <p:txBody>
-          <a:bodyPr wrap="square" lIns="0" tIns="0" rIns="0" bIns="0" rtlCol="0" anchor="ctr"/>
-          <a:lstStyle/>
-          <a:p>
-            <a:pPr indent="0" marL="0">
-              <a:buNone/>
-            </a:pPr>
-            <a:r>
-              <a:rPr lang="en-US" sz="1200" b="1" dirty="0">
-                <a:solidFill>
-                  <a:srgbClr val="FFFFFF"/>
-                </a:solidFill>
-                <a:latin typeface="Calibri" pitchFamily="34" charset="0"/>
-                <a:ea typeface="Calibri" pitchFamily="34" charset="-122"/>
-                <a:cs typeface="Calibri" pitchFamily="34" charset="-120"/>
-              </a:rPr>
-              <a:t>Agent graph model  </a:t>
-            </a:r>
-            <a:pPr indent="0" marL="0">
-              <a:buNone/>
-            </a:pPr>
-            <a:r>
-              <a:rPr lang="en-US" sz="1100" dirty="0">
-                <a:solidFill>
-                  <a:srgbClr val="E8EEFC"/>
-                </a:solidFill>
-                <a:latin typeface="Calibri" pitchFamily="34" charset="0"/>
-                <a:ea typeface="Calibri" pitchFamily="34" charset="-122"/>
-                <a:cs typeface="Calibri" pitchFamily="34" charset="-120"/>
-              </a:rPr>
-              <a:t>First-class entity</a:t>
-            </a:r>
-            <a:endParaRPr lang="en-US" sz="1200" dirty="0"/>
-          </a:p>
-        </p:txBody>
-      </p:sp>
-      <p:sp>
-        <p:nvSpPr>
-          <p:cNvPr id="14" name="Shape 12"/>
-          <p:cNvSpPr/>
-          <p:nvPr/>
-        </p:nvSpPr>
-        <p:spPr>
-          <a:xfrm>
-            <a:off x="5010912" y="2578608"/>
-            <a:ext cx="201168" cy="201168"/>
-          </a:xfrm>
-          <a:prstGeom prst="ellipse">
-            <a:avLst/>
-          </a:prstGeom>
-          <a:solidFill>
-            <a:srgbClr val="02C39A"/>
-          </a:solidFill>
-          <a:ln w="12700">
-            <a:solidFill>
-              <a:srgbClr val="02C39A"/>
-            </a:solidFill>
-            <a:prstDash val="solid"/>
-          </a:ln>
-        </p:spPr>
-      </p:sp>
-      <p:sp>
-        <p:nvSpPr>
-          <p:cNvPr id="15" name="Text 13"/>
-          <p:cNvSpPr/>
-          <p:nvPr/>
-        </p:nvSpPr>
-        <p:spPr>
-          <a:xfrm>
-            <a:off x="5303520" y="2514600"/>
-            <a:ext cx="3200400" cy="457200"/>
-          </a:xfrm>
-          <a:prstGeom prst="rect">
-            <a:avLst/>
-          </a:prstGeom>
-          <a:noFill/>
-          <a:ln/>
-        </p:spPr>
-        <p:txBody>
-          <a:bodyPr wrap="square" lIns="0" tIns="0" rIns="0" bIns="0" rtlCol="0" anchor="ctr"/>
-          <a:lstStyle/>
-          <a:p>
-            <a:pPr indent="0" marL="0">
-              <a:buNone/>
-            </a:pPr>
-            <a:r>
-              <a:rPr lang="en-US" sz="1200" b="1" dirty="0">
-                <a:solidFill>
-                  <a:srgbClr val="FFFFFF"/>
-                </a:solidFill>
-                <a:latin typeface="Calibri" pitchFamily="34" charset="0"/>
-                <a:ea typeface="Calibri" pitchFamily="34" charset="-122"/>
-                <a:cs typeface="Calibri" pitchFamily="34" charset="-120"/>
-              </a:rPr>
-              <a:t>Discovery &gt; Agents UI  </a:t>
-            </a:r>
-            <a:pPr indent="0" marL="0">
-              <a:buNone/>
-            </a:pPr>
-            <a:r>
-              <a:rPr lang="en-US" sz="1100" dirty="0">
-                <a:solidFill>
-                  <a:srgbClr val="E8EEFC"/>
-                </a:solidFill>
-                <a:latin typeface="Calibri" pitchFamily="34" charset="0"/>
-                <a:ea typeface="Calibri" pitchFamily="34" charset="-122"/>
-                <a:cs typeface="Calibri" pitchFamily="34" charset="-120"/>
-              </a:rPr>
-              <a:t>Live data</a:t>
-            </a:r>
-            <a:endParaRPr lang="en-US" sz="1200" dirty="0"/>
-          </a:p>
-        </p:txBody>
-      </p:sp>
-      <p:sp>
-        <p:nvSpPr>
-          <p:cNvPr id="16" name="Shape 14"/>
-          <p:cNvSpPr/>
-          <p:nvPr/>
-        </p:nvSpPr>
-        <p:spPr>
-          <a:xfrm>
-            <a:off x="5010912" y="3081528"/>
-            <a:ext cx="201168" cy="201168"/>
-          </a:xfrm>
-          <a:prstGeom prst="ellipse">
-            <a:avLst/>
-          </a:prstGeom>
-          <a:solidFill>
-            <a:srgbClr val="02C39A"/>
-          </a:solidFill>
-          <a:ln w="12700">
-            <a:solidFill>
-              <a:srgbClr val="02C39A"/>
-            </a:solidFill>
-            <a:prstDash val="solid"/>
-          </a:ln>
-        </p:spPr>
-      </p:sp>
-      <p:sp>
-        <p:nvSpPr>
-          <p:cNvPr id="17" name="Text 15"/>
-          <p:cNvSpPr/>
-          <p:nvPr/>
-        </p:nvSpPr>
-        <p:spPr>
-          <a:xfrm>
-            <a:off x="5303520" y="3017520"/>
-            <a:ext cx="3200400" cy="457200"/>
-          </a:xfrm>
-          <a:prstGeom prst="rect">
-            <a:avLst/>
-          </a:prstGeom>
-          <a:noFill/>
-          <a:ln/>
-        </p:spPr>
-        <p:txBody>
-          <a:bodyPr wrap="square" lIns="0" tIns="0" rIns="0" bIns="0" rtlCol="0" anchor="ctr"/>
-          <a:lstStyle/>
-          <a:p>
-            <a:pPr indent="0" marL="0">
-              <a:buNone/>
-            </a:pPr>
-            <a:r>
-              <a:rPr lang="en-US" sz="1200" b="1" dirty="0">
-                <a:solidFill>
-                  <a:srgbClr val="FFFFFF"/>
-                </a:solidFill>
-                <a:latin typeface="Calibri" pitchFamily="34" charset="0"/>
-                <a:ea typeface="Calibri" pitchFamily="34" charset="-122"/>
-                <a:cs typeface="Calibri" pitchFamily="34" charset="-120"/>
-              </a:rPr>
-              <a:t>Connectors  </a:t>
-            </a:r>
-            <a:pPr indent="0" marL="0">
-              <a:buNone/>
-            </a:pPr>
-            <a:r>
-              <a:rPr lang="en-US" sz="1100" dirty="0">
-                <a:solidFill>
-                  <a:srgbClr val="E8EEFC"/>
-                </a:solidFill>
-                <a:latin typeface="Calibri" pitchFamily="34" charset="0"/>
-                <a:ea typeface="Calibri" pitchFamily="34" charset="-122"/>
-                <a:cs typeface="Calibri" pitchFamily="34" charset="-120"/>
-              </a:rPr>
-              <a:t>Gemini · Vertex AI · Bedrock · n8n</a:t>
-            </a:r>
-            <a:endParaRPr lang="en-US" sz="1200" dirty="0"/>
-          </a:p>
-        </p:txBody>
-      </p:sp>
-      <p:sp>
-        <p:nvSpPr>
-          <p:cNvPr id="18" name="Shape 16"/>
-          <p:cNvSpPr/>
-          <p:nvPr/>
-        </p:nvSpPr>
-        <p:spPr>
-          <a:xfrm>
-            <a:off x="5010912" y="3584448"/>
-            <a:ext cx="201168" cy="201168"/>
-          </a:xfrm>
-          <a:prstGeom prst="ellipse">
-            <a:avLst/>
-          </a:prstGeom>
-          <a:solidFill>
-            <a:srgbClr val="02C39A"/>
-          </a:solidFill>
-          <a:ln w="12700">
-            <a:solidFill>
-              <a:srgbClr val="02C39A"/>
-            </a:solidFill>
-            <a:prstDash val="solid"/>
-          </a:ln>
-        </p:spPr>
-      </p:sp>
-      <p:sp>
-        <p:nvSpPr>
-          <p:cNvPr id="19" name="Text 17"/>
-          <p:cNvSpPr/>
-          <p:nvPr/>
-        </p:nvSpPr>
-        <p:spPr>
-          <a:xfrm>
-            <a:off x="5303520" y="3520440"/>
-            <a:ext cx="3200400" cy="457200"/>
-          </a:xfrm>
-          <a:prstGeom prst="rect">
-            <a:avLst/>
-          </a:prstGeom>
-          <a:noFill/>
-          <a:ln/>
-        </p:spPr>
-        <p:txBody>
-          <a:bodyPr wrap="square" lIns="0" tIns="0" rIns="0" bIns="0" rtlCol="0" anchor="ctr"/>
-          <a:lstStyle/>
-          <a:p>
-            <a:pPr indent="0" marL="0">
-              <a:buNone/>
-            </a:pPr>
-            <a:r>
-              <a:rPr lang="en-US" sz="1200" b="1" dirty="0">
-                <a:solidFill>
-                  <a:srgbClr val="FFFFFF"/>
-                </a:solidFill>
-                <a:latin typeface="Calibri" pitchFamily="34" charset="0"/>
-                <a:ea typeface="Calibri" pitchFamily="34" charset="-122"/>
-                <a:cs typeface="Calibri" pitchFamily="34" charset="-120"/>
-              </a:rPr>
-              <a:t>Built-in issues  </a:t>
-            </a:r>
-            <a:pPr indent="0" marL="0">
-              <a:buNone/>
-            </a:pPr>
-            <a:r>
-              <a:rPr lang="en-US" sz="1100" dirty="0">
-                <a:solidFill>
-                  <a:srgbClr val="E8EEFC"/>
-                </a:solidFill>
-                <a:latin typeface="Calibri" pitchFamily="34" charset="0"/>
-                <a:ea typeface="Calibri" pitchFamily="34" charset="-122"/>
-                <a:cs typeface="Calibri" pitchFamily="34" charset="-120"/>
-              </a:rPr>
-              <a:t>AGENT_EXCESSIVE_PERMISSIONS, AGENT_OWNER_OFFBOARDED</a:t>
-            </a:r>
-            <a:endParaRPr lang="en-US" sz="1200" dirty="0"/>
           </a:p>
         </p:txBody>
       </p:sp>
@@ -3216,7 +3216,7 @@
                 <a:ea typeface="Calibri" pitchFamily="34" charset="-122"/>
                 <a:cs typeface="Calibri" pitchFamily="34" charset="-120"/>
               </a:rPr>
-              <a:t>Agents are the fastest-growing identity category. We want to be the one-stop shop — this is the moment. Race is on: Saviynt, Token Security, Astrix all converging here.</a:t>
+              <a:t>Agents are the fastest-growing identity category — we want to be the one-stop shop. If Saviynt or Token Security defines MCP governance at Identiverse and we don't show up, that category is theirs.</a:t>
             </a:r>
             <a:endParaRPr lang="en-US" sz="1000" dirty="0"/>
           </a:p>
@@ -5136,7 +5136,7 @@
                 <a:ea typeface="Calibri" pitchFamily="34" charset="-122"/>
                 <a:cs typeface="Calibri" pitchFamily="34" charset="-120"/>
               </a:rPr>
-              <a:t>Options mapped: build vs. adopt</a:t>
+              <a:t>Options: build vs. adopt · M1/M2 inputs</a:t>
             </a:r>
             <a:endParaRPr lang="en-US" sz="1100" dirty="0"/>
           </a:p>
@@ -5157,7 +5157,7 @@
                 <a:ea typeface="Calibri" pitchFamily="34" charset="-122"/>
                 <a:cs typeface="Calibri" pitchFamily="34" charset="-120"/>
               </a:rPr>
-              <a:t>What from M1/M2 feeds in</a:t>
+              <a:t>Apr 27 research → May 11 POC check</a:t>
             </a:r>
             <a:endParaRPr lang="en-US" sz="1100" dirty="0"/>
           </a:p>
@@ -5177,7 +5177,7 @@
                 <a:ea typeface="Calibri" pitchFamily="34" charset="-122"/>
                 <a:cs typeface="Calibri" pitchFamily="34" charset="-120"/>
               </a:rPr>
-              <a:t>→ First sync: Wednesday</a:t>
+              <a:t>→ Jun 1 integration · Jun 15 demo</a:t>
             </a:r>
             <a:endParaRPr lang="en-US" sz="1100" dirty="0"/>
           </a:p>
@@ -5280,7 +5280,7 @@
                 <a:ea typeface="Georgia" pitchFamily="34" charset="-122"/>
                 <a:cs typeface="Georgia" pitchFamily="34" charset="-120"/>
               </a:rPr>
-              <a:t>Demo defined</a:t>
+              <a:t>Demo format picked</a:t>
             </a:r>
             <a:endParaRPr lang="en-US" sz="1400" dirty="0"/>
           </a:p>
@@ -5348,7 +5348,7 @@
                 <a:ea typeface="Calibri" pitchFamily="34" charset="-122"/>
                 <a:cs typeface="Calibri" pitchFamily="34" charset="-120"/>
               </a:rPr>
-              <a:t>What does "works on June 15" mean?</a:t>
+              <a:t>Thin live: Gateway + 1 connector + 1 policy, live</a:t>
             </a:r>
             <a:endParaRPr lang="en-US" sz="1100" dirty="0"/>
           </a:p>
@@ -5369,7 +5369,7 @@
                 <a:ea typeface="Calibri" pitchFamily="34" charset="-122"/>
                 <a:cs typeface="Calibri" pitchFamily="34" charset="-120"/>
               </a:rPr>
-              <a:t>Live integration or canned flow?</a:t>
+              <a:t>Wide canned: all 3 components, scripted</a:t>
             </a:r>
             <a:endParaRPr lang="en-US" sz="1100" dirty="0"/>
           </a:p>
@@ -5390,7 +5390,7 @@
                 <a:ea typeface="Calibri" pitchFamily="34" charset="-122"/>
                 <a:cs typeface="Calibri" pitchFamily="34" charset="-120"/>
               </a:rPr>
-              <a:t>Which agent? Which tools?</a:t>
+              <a:t>Hybrid: Gateway live, rest scripted</a:t>
             </a:r>
             <a:endParaRPr lang="en-US" sz="1100" dirty="0"/>
           </a:p>
@@ -5410,7 +5410,7 @@
                 <a:ea typeface="Calibri" pitchFamily="34" charset="-122"/>
                 <a:cs typeface="Calibri" pitchFamily="34" charset="-120"/>
               </a:rPr>
-              <a:t>→ Scope locked, not aspirational</a:t>
+              <a:t>→ Room picks one</a:t>
             </a:r>
             <a:endParaRPr lang="en-US" sz="1100" dirty="0"/>
           </a:p>

</xml_diff>

<commit_message>
Deck v10: source 144:1 stat, redesign closing slide as Go.
- Fix "fastest-growing" claim → sourced 144:1 (SACR 2026)
- Replace outcome A/B/C with 3-workstream owner grid: Gateway Core (Javier+Omer) / Scope+Competitive (Omri) / Architecture (Sarit+Amir)
- First sync: Wednesday on all 3 tracks
- Amber footer: P0 for Linx, Omri+Sarit tracking weekly, June 15 is the line

Co-Authored-By: Claude Sonnet 4.6 <noreply@anthropic.com>
</commit_message>
<xml_diff>
--- a/artifacts/eng-prekickoff-2026-04-27.pptx
+++ b/artifacts/eng-prekickoff-2026-04-27.pptx
@@ -3216,7 +3216,7 @@
                 <a:ea typeface="Calibri" pitchFamily="34" charset="-122"/>
                 <a:cs typeface="Calibri" pitchFamily="34" charset="-120"/>
               </a:rPr>
-              <a:t>Agents are the fastest-growing identity category — we want to be the one-stop shop. If Saviynt or Token Security defines MCP governance at Identiverse and we don't show up, that category is theirs.</a:t>
+              <a:t>Agent identities now outpace every other identity class — 144:1 in deployed enterprises (SACR, 2026). If Saviynt or Token Security defines MCP governance at Identiverse and we don't show up, that category is theirs.</a:t>
             </a:r>
             <a:endParaRPr lang="en-US" sz="1000" dirty="0"/>
           </a:p>
@@ -4620,7 +4620,7 @@
         </p:nvSpPr>
         <p:spPr>
           <a:xfrm>
-            <a:off x="-1371600" y="3200400"/>
+            <a:off x="6858000" y="2286000"/>
             <a:ext cx="4572000" cy="4572000"/>
           </a:xfrm>
           <a:prstGeom prst="ellipse">
@@ -4628,7 +4628,7 @@
           </a:prstGeom>
           <a:solidFill>
             <a:srgbClr val="02C39A">
-              <a:alpha val="15000"/>
+              <a:alpha val="12000"/>
             </a:srgbClr>
           </a:solidFill>
           <a:ln w="12700">
@@ -4672,7 +4672,7 @@
                 <a:ea typeface="Calibri" pitchFamily="34" charset="-122"/>
                 <a:cs typeface="Calibri" pitchFamily="34" charset="-120"/>
               </a:rPr>
-              <a:t>04 · We leave with</a:t>
+              <a:t>05 · Aligned. Now go.</a:t>
             </a:r>
             <a:endParaRPr lang="en-US" sz="1100" dirty="0"/>
           </a:p>
@@ -4686,24 +4686,24 @@
         </p:nvSpPr>
         <p:spPr>
           <a:xfrm>
-            <a:off x="457200" y="685800"/>
-            <a:ext cx="8229600" cy="685800"/>
-          </a:xfrm>
-          <a:prstGeom prst="rect">
-            <a:avLst/>
-          </a:prstGeom>
-          <a:noFill/>
-          <a:ln/>
-        </p:spPr>
-        <p:txBody>
-          <a:bodyPr wrap="square" lIns="0" tIns="0" rIns="0" bIns="0" rtlCol="0" anchor="ctr"/>
-          <a:lstStyle/>
-          <a:p>
-            <a:pPr indent="0" marL="0">
-              <a:buNone/>
-            </a:pPr>
-            <a:r>
-              <a:rPr lang="en-US" sz="3000" b="1" dirty="0">
+            <a:off x="457200" y="658368"/>
+            <a:ext cx="2743200" cy="914400"/>
+          </a:xfrm>
+          <a:prstGeom prst="rect">
+            <a:avLst/>
+          </a:prstGeom>
+          <a:noFill/>
+          <a:ln/>
+        </p:spPr>
+        <p:txBody>
+          <a:bodyPr wrap="square" lIns="0" tIns="0" rIns="0" bIns="0" rtlCol="0" anchor="ctr"/>
+          <a:lstStyle/>
+          <a:p>
+            <a:pPr indent="0" marL="0">
+              <a:buNone/>
+            </a:pPr>
+            <a:r>
+              <a:rPr lang="en-US" sz="7200" b="1" dirty="0">
                 <a:solidFill>
                   <a:srgbClr val="FFFFFF"/>
                 </a:solidFill>
@@ -4711,22 +4711,61 @@
                 <a:ea typeface="Georgia" pitchFamily="34" charset="-122"/>
                 <a:cs typeface="Georgia" pitchFamily="34" charset="-120"/>
               </a:rPr>
-              <a:t>Three outputs. Not discussion topics.</a:t>
-            </a:r>
-            <a:endParaRPr lang="en-US" sz="3000" dirty="0"/>
-          </a:p>
-        </p:txBody>
-      </p:sp>
-      <p:sp>
-        <p:nvSpPr>
-          <p:cNvPr id="5" name="Shape 3"/>
-          <p:cNvSpPr/>
-          <p:nvPr/>
-        </p:nvSpPr>
-        <p:spPr>
-          <a:xfrm>
-            <a:off x="406908" y="1645920"/>
-            <a:ext cx="2697480" cy="475488"/>
+              <a:t>Go.</a:t>
+            </a:r>
+            <a:endParaRPr lang="en-US" sz="7200" dirty="0"/>
+          </a:p>
+        </p:txBody>
+      </p:sp>
+      <p:sp>
+        <p:nvSpPr>
+          <p:cNvPr id="5" name="Text 3"/>
+          <p:cNvSpPr/>
+          <p:nvPr/>
+        </p:nvSpPr>
+        <p:spPr>
+          <a:xfrm>
+            <a:off x="457200" y="1572768"/>
+            <a:ext cx="7772400" cy="365760"/>
+          </a:xfrm>
+          <a:prstGeom prst="rect">
+            <a:avLst/>
+          </a:prstGeom>
+          <a:noFill/>
+          <a:ln/>
+        </p:spPr>
+        <p:txBody>
+          <a:bodyPr wrap="square" lIns="0" tIns="0" rIns="0" bIns="0" rtlCol="0" anchor="ctr"/>
+          <a:lstStyle/>
+          <a:p>
+            <a:pPr indent="0" marL="0">
+              <a:buNone/>
+            </a:pPr>
+            <a:r>
+              <a:rPr lang="en-US" sz="1500" i="1" dirty="0">
+                <a:solidFill>
+                  <a:srgbClr val="E8EEFC"/>
+                </a:solidFill>
+                <a:latin typeface="Calibri" pitchFamily="34" charset="0"/>
+                <a:ea typeface="Calibri" pitchFamily="34" charset="-122"/>
+                <a:cs typeface="Calibri" pitchFamily="34" charset="-120"/>
+              </a:rPr>
+              <a:t>Three workstreams start today. One cadence. June 15.</a:t>
+            </a:r>
+            <a:endParaRPr lang="en-US" sz="1500" dirty="0"/>
+          </a:p>
+        </p:txBody>
+      </p:sp>
+      <p:sp>
+        <p:nvSpPr>
+          <p:cNvPr id="6" name="Shape 4"/>
+          <p:cNvSpPr/>
+          <p:nvPr/>
+        </p:nvSpPr>
+        <p:spPr>
+          <a:xfrm>
+            <a:off x="434340" y="2103120"/>
+            <a:ext cx="2697480" cy="658368"/>
           </a:xfrm>
           <a:prstGeom prst="rect">
             <a:avLst/>
@@ -4744,92 +4783,92 @@
       </p:sp>
       <p:sp>
         <p:nvSpPr>
-          <p:cNvPr id="6" name="Text 4"/>
-          <p:cNvSpPr/>
-          <p:nvPr/>
-        </p:nvSpPr>
-        <p:spPr>
-          <a:xfrm>
-            <a:off x="406908" y="1645920"/>
-            <a:ext cx="475488" cy="475488"/>
-          </a:xfrm>
-          <a:prstGeom prst="rect">
-            <a:avLst/>
-          </a:prstGeom>
-          <a:noFill/>
-          <a:ln/>
-        </p:spPr>
-        <p:txBody>
-          <a:bodyPr wrap="square" lIns="0" tIns="0" rIns="0" bIns="0" rtlCol="0" anchor="ctr"/>
-          <a:lstStyle/>
-          <a:p>
-            <a:pPr algn="ctr" indent="0" marL="0">
-              <a:buNone/>
-            </a:pPr>
-            <a:r>
-              <a:rPr lang="en-US" sz="2200" b="1" dirty="0">
+          <p:cNvPr id="7" name="Text 5"/>
+          <p:cNvSpPr/>
+          <p:nvPr/>
+        </p:nvSpPr>
+        <p:spPr>
+          <a:xfrm>
+            <a:off x="571500" y="2148840"/>
+            <a:ext cx="2423160" cy="256032"/>
+          </a:xfrm>
+          <a:prstGeom prst="rect">
+            <a:avLst/>
+          </a:prstGeom>
+          <a:noFill/>
+          <a:ln/>
+        </p:spPr>
+        <p:txBody>
+          <a:bodyPr wrap="square" lIns="0" tIns="0" rIns="0" bIns="0" rtlCol="0" anchor="ctr"/>
+          <a:lstStyle/>
+          <a:p>
+            <a:pPr indent="0" marL="0">
+              <a:buNone/>
+            </a:pPr>
+            <a:r>
+              <a:rPr lang="en-US" sz="1000" b="1" spc="300" kern="0" dirty="0">
                 <a:solidFill>
                   <a:srgbClr val="0F1B3D"/>
+                </a:solidFill>
+                <a:latin typeface="Calibri" pitchFamily="34" charset="0"/>
+                <a:ea typeface="Calibri" pitchFamily="34" charset="-122"/>
+                <a:cs typeface="Calibri" pitchFamily="34" charset="-120"/>
+              </a:rPr>
+              <a:t>GATEWAY CORE</a:t>
+            </a:r>
+            <a:endParaRPr lang="en-US" sz="1000" dirty="0"/>
+          </a:p>
+        </p:txBody>
+      </p:sp>
+      <p:sp>
+        <p:nvSpPr>
+          <p:cNvPr id="8" name="Text 6"/>
+          <p:cNvSpPr/>
+          <p:nvPr/>
+        </p:nvSpPr>
+        <p:spPr>
+          <a:xfrm>
+            <a:off x="571500" y="2450592"/>
+            <a:ext cx="2423160" cy="256032"/>
+          </a:xfrm>
+          <a:prstGeom prst="rect">
+            <a:avLst/>
+          </a:prstGeom>
+          <a:noFill/>
+          <a:ln/>
+        </p:spPr>
+        <p:txBody>
+          <a:bodyPr wrap="square" lIns="0" tIns="0" rIns="0" bIns="0" rtlCol="0" anchor="ctr"/>
+          <a:lstStyle/>
+          <a:p>
+            <a:pPr indent="0" marL="0">
+              <a:buNone/>
+            </a:pPr>
+            <a:r>
+              <a:rPr lang="en-US" sz="1200" b="1" dirty="0">
+                <a:solidFill>
+                  <a:srgbClr val="091230"/>
                 </a:solidFill>
                 <a:latin typeface="Georgia" pitchFamily="34" charset="0"/>
                 <a:ea typeface="Georgia" pitchFamily="34" charset="-122"/>
                 <a:cs typeface="Georgia" pitchFamily="34" charset="-120"/>
               </a:rPr>
-              <a:t>A</a:t>
-            </a:r>
-            <a:endParaRPr lang="en-US" sz="2200" dirty="0"/>
-          </a:p>
-        </p:txBody>
-      </p:sp>
-      <p:sp>
-        <p:nvSpPr>
-          <p:cNvPr id="7" name="Text 5"/>
-          <p:cNvSpPr/>
-          <p:nvPr/>
-        </p:nvSpPr>
-        <p:spPr>
-          <a:xfrm>
-            <a:off x="937260" y="1709928"/>
-            <a:ext cx="2103120" cy="384048"/>
-          </a:xfrm>
-          <a:prstGeom prst="rect">
-            <a:avLst/>
-          </a:prstGeom>
-          <a:noFill/>
-          <a:ln/>
-        </p:spPr>
-        <p:txBody>
-          <a:bodyPr wrap="square" lIns="0" tIns="0" rIns="0" bIns="0" rtlCol="0" anchor="ctr"/>
-          <a:lstStyle/>
-          <a:p>
-            <a:pPr indent="0" marL="0">
-              <a:buNone/>
-            </a:pPr>
-            <a:r>
-              <a:rPr lang="en-US" sz="1400" b="1" dirty="0">
-                <a:solidFill>
-                  <a:srgbClr val="0F1B3D"/>
-                </a:solidFill>
-                <a:latin typeface="Georgia" pitchFamily="34" charset="0"/>
-                <a:ea typeface="Georgia" pitchFamily="34" charset="-122"/>
-                <a:cs typeface="Georgia" pitchFamily="34" charset="-120"/>
-              </a:rPr>
-              <a:t>P0 status snapshot</a:t>
-            </a:r>
-            <a:endParaRPr lang="en-US" sz="1400" dirty="0"/>
-          </a:p>
-        </p:txBody>
-      </p:sp>
-      <p:sp>
-        <p:nvSpPr>
-          <p:cNvPr id="8" name="Shape 6"/>
-          <p:cNvSpPr/>
-          <p:nvPr/>
-        </p:nvSpPr>
-        <p:spPr>
-          <a:xfrm>
-            <a:off x="406908" y="2121408"/>
-            <a:ext cx="2697480" cy="2267712"/>
+              <a:t>Javier + Omer Blechman</a:t>
+            </a:r>
+            <a:endParaRPr lang="en-US" sz="1200" dirty="0"/>
+          </a:p>
+        </p:txBody>
+      </p:sp>
+      <p:sp>
+        <p:nvSpPr>
+          <p:cNvPr id="9" name="Shape 7"/>
+          <p:cNvSpPr/>
+          <p:nvPr/>
+        </p:nvSpPr>
+        <p:spPr>
+          <a:xfrm>
+            <a:off x="434340" y="2761488"/>
+            <a:ext cx="2697480" cy="1673352"/>
           </a:xfrm>
           <a:prstGeom prst="rect">
             <a:avLst/>
@@ -4847,14 +4886,14 @@
       </p:sp>
       <p:sp>
         <p:nvSpPr>
-          <p:cNvPr id="9" name="Text 7"/>
-          <p:cNvSpPr/>
-          <p:nvPr/>
-        </p:nvSpPr>
-        <p:spPr>
-          <a:xfrm>
-            <a:off x="589788" y="2267712"/>
-            <a:ext cx="2331720" cy="1993392"/>
+          <p:cNvPr id="10" name="Text 8"/>
+          <p:cNvSpPr/>
+          <p:nvPr/>
+        </p:nvSpPr>
+        <p:spPr>
+          <a:xfrm>
+            <a:off x="598932" y="2907792"/>
+            <a:ext cx="2368296" cy="1417320"/>
           </a:xfrm>
           <a:prstGeom prst="rect">
             <a:avLst/>
@@ -4868,7 +4907,7 @@
           <a:p>
             <a:pPr marL="342900" indent="-342900">
               <a:spcAft>
-                <a:spcPts val="500"/>
+                <a:spcPts val="400"/>
               </a:spcAft>
               <a:buSzPct val="100000"/>
               <a:buChar char="■"/>
@@ -4882,14 +4921,14 @@
                 <a:ea typeface="Calibri" pitchFamily="34" charset="-122"/>
                 <a:cs typeface="Calibri" pitchFamily="34" charset="-120"/>
               </a:rPr>
-              <a:t>Gateway Core: what exists, what doesn't</a:t>
+              <a:t>Research: build vs. adopt, options + coverage</a:t>
             </a:r>
             <a:endParaRPr lang="en-US" sz="1100" dirty="0"/>
           </a:p>
           <a:p>
             <a:pPr marL="342900" indent="-342900">
               <a:spcAft>
-                <a:spcPts val="500"/>
+                <a:spcPts val="400"/>
               </a:spcAft>
               <a:buSzPct val="100000"/>
               <a:buChar char="■"/>
@@ -4903,14 +4942,14 @@
                 <a:ea typeface="Calibri" pitchFamily="34" charset="-122"/>
                 <a:cs typeface="Calibri" pitchFamily="34" charset="-120"/>
               </a:rPr>
-              <a:t>Policy Agent: same</a:t>
+              <a:t>Map what existing work feeds in</a:t>
             </a:r>
             <a:endParaRPr lang="en-US" sz="1100" dirty="0"/>
           </a:p>
           <a:p>
             <a:pPr marL="342900" indent="-342900">
               <a:spcAft>
-                <a:spcPts val="500"/>
+                <a:spcPts val="400"/>
               </a:spcAft>
               <a:buSzPct val="100000"/>
               <a:buChar char="■"/>
@@ -4924,14 +4963,14 @@
                 <a:ea typeface="Calibri" pitchFamily="34" charset="-122"/>
                 <a:cs typeface="Calibri" pitchFamily="34" charset="-120"/>
               </a:rPr>
-              <a:t>Screens: design started?</a:t>
+              <a:t>Draft POC plan</a:t>
             </a:r>
             <a:endParaRPr lang="en-US" sz="1100" dirty="0"/>
           </a:p>
           <a:p>
             <a:pPr indent="0" marL="0">
               <a:spcAft>
-                <a:spcPts val="500"/>
+                <a:spcPts val="400"/>
               </a:spcAft>
               <a:buNone/>
             </a:pPr>
@@ -4944,7 +4983,7 @@
                 <a:ea typeface="Calibri" pitchFamily="34" charset="-122"/>
                 <a:cs typeface="Calibri" pitchFamily="34" charset="-120"/>
               </a:rPr>
-              <a:t>→ Shared picture, no gaps</a:t>
+              <a:t>→ First sync: Wednesday</a:t>
             </a:r>
             <a:endParaRPr lang="en-US" sz="1100" dirty="0"/>
           </a:p>
@@ -4952,14 +4991,14 @@
       </p:sp>
       <p:sp>
         <p:nvSpPr>
-          <p:cNvPr id="10" name="Shape 8"/>
-          <p:cNvSpPr/>
-          <p:nvPr/>
-        </p:nvSpPr>
-        <p:spPr>
-          <a:xfrm>
-            <a:off x="3223260" y="1645920"/>
-            <a:ext cx="2697480" cy="475488"/>
+          <p:cNvPr id="11" name="Shape 9"/>
+          <p:cNvSpPr/>
+          <p:nvPr/>
+        </p:nvSpPr>
+        <p:spPr>
+          <a:xfrm>
+            <a:off x="3223260" y="2103120"/>
+            <a:ext cx="2697480" cy="658368"/>
           </a:xfrm>
           <a:prstGeom prst="rect">
             <a:avLst/>
@@ -4977,92 +5016,92 @@
       </p:sp>
       <p:sp>
         <p:nvSpPr>
-          <p:cNvPr id="11" name="Text 9"/>
-          <p:cNvSpPr/>
-          <p:nvPr/>
-        </p:nvSpPr>
-        <p:spPr>
-          <a:xfrm>
-            <a:off x="3223260" y="1645920"/>
-            <a:ext cx="475488" cy="475488"/>
-          </a:xfrm>
-          <a:prstGeom prst="rect">
-            <a:avLst/>
-          </a:prstGeom>
-          <a:noFill/>
-          <a:ln/>
-        </p:spPr>
-        <p:txBody>
-          <a:bodyPr wrap="square" lIns="0" tIns="0" rIns="0" bIns="0" rtlCol="0" anchor="ctr"/>
-          <a:lstStyle/>
-          <a:p>
-            <a:pPr algn="ctr" indent="0" marL="0">
-              <a:buNone/>
-            </a:pPr>
-            <a:r>
-              <a:rPr lang="en-US" sz="2200" b="1" dirty="0">
+          <p:cNvPr id="12" name="Text 10"/>
+          <p:cNvSpPr/>
+          <p:nvPr/>
+        </p:nvSpPr>
+        <p:spPr>
+          <a:xfrm>
+            <a:off x="3360420" y="2148840"/>
+            <a:ext cx="2423160" cy="256032"/>
+          </a:xfrm>
+          <a:prstGeom prst="rect">
+            <a:avLst/>
+          </a:prstGeom>
+          <a:noFill/>
+          <a:ln/>
+        </p:spPr>
+        <p:txBody>
+          <a:bodyPr wrap="square" lIns="0" tIns="0" rIns="0" bIns="0" rtlCol="0" anchor="ctr"/>
+          <a:lstStyle/>
+          <a:p>
+            <a:pPr indent="0" marL="0">
+              <a:buNone/>
+            </a:pPr>
+            <a:r>
+              <a:rPr lang="en-US" sz="1000" b="1" spc="300" kern="0" dirty="0">
                 <a:solidFill>
                   <a:srgbClr val="0F1B3D"/>
+                </a:solidFill>
+                <a:latin typeface="Calibri" pitchFamily="34" charset="0"/>
+                <a:ea typeface="Calibri" pitchFamily="34" charset="-122"/>
+                <a:cs typeface="Calibri" pitchFamily="34" charset="-120"/>
+              </a:rPr>
+              <a:t>SCOPE + COMPETITIVE</a:t>
+            </a:r>
+            <a:endParaRPr lang="en-US" sz="1000" dirty="0"/>
+          </a:p>
+        </p:txBody>
+      </p:sp>
+      <p:sp>
+        <p:nvSpPr>
+          <p:cNvPr id="13" name="Text 11"/>
+          <p:cNvSpPr/>
+          <p:nvPr/>
+        </p:nvSpPr>
+        <p:spPr>
+          <a:xfrm>
+            <a:off x="3360420" y="2450592"/>
+            <a:ext cx="2423160" cy="256032"/>
+          </a:xfrm>
+          <a:prstGeom prst="rect">
+            <a:avLst/>
+          </a:prstGeom>
+          <a:noFill/>
+          <a:ln/>
+        </p:spPr>
+        <p:txBody>
+          <a:bodyPr wrap="square" lIns="0" tIns="0" rIns="0" bIns="0" rtlCol="0" anchor="ctr"/>
+          <a:lstStyle/>
+          <a:p>
+            <a:pPr indent="0" marL="0">
+              <a:buNone/>
+            </a:pPr>
+            <a:r>
+              <a:rPr lang="en-US" sz="1200" b="1" dirty="0">
+                <a:solidFill>
+                  <a:srgbClr val="091230"/>
                 </a:solidFill>
                 <a:latin typeface="Georgia" pitchFamily="34" charset="0"/>
                 <a:ea typeface="Georgia" pitchFamily="34" charset="-122"/>
                 <a:cs typeface="Georgia" pitchFamily="34" charset="-120"/>
               </a:rPr>
-              <a:t>B</a:t>
-            </a:r>
-            <a:endParaRPr lang="en-US" sz="2200" dirty="0"/>
-          </a:p>
-        </p:txBody>
-      </p:sp>
-      <p:sp>
-        <p:nvSpPr>
-          <p:cNvPr id="12" name="Text 10"/>
-          <p:cNvSpPr/>
-          <p:nvPr/>
-        </p:nvSpPr>
-        <p:spPr>
-          <a:xfrm>
-            <a:off x="3753612" y="1709928"/>
-            <a:ext cx="2103120" cy="384048"/>
-          </a:xfrm>
-          <a:prstGeom prst="rect">
-            <a:avLst/>
-          </a:prstGeom>
-          <a:noFill/>
-          <a:ln/>
-        </p:spPr>
-        <p:txBody>
-          <a:bodyPr wrap="square" lIns="0" tIns="0" rIns="0" bIns="0" rtlCol="0" anchor="ctr"/>
-          <a:lstStyle/>
-          <a:p>
-            <a:pPr indent="0" marL="0">
-              <a:buNone/>
-            </a:pPr>
-            <a:r>
-              <a:rPr lang="en-US" sz="1400" b="1" dirty="0">
-                <a:solidFill>
-                  <a:srgbClr val="0F1B3D"/>
-                </a:solidFill>
-                <a:latin typeface="Georgia" pitchFamily="34" charset="0"/>
-                <a:ea typeface="Georgia" pitchFamily="34" charset="-122"/>
-                <a:cs typeface="Georgia" pitchFamily="34" charset="-120"/>
-              </a:rPr>
-              <a:t>Gateway Core POC plan</a:t>
-            </a:r>
-            <a:endParaRPr lang="en-US" sz="1400" dirty="0"/>
-          </a:p>
-        </p:txBody>
-      </p:sp>
-      <p:sp>
-        <p:nvSpPr>
-          <p:cNvPr id="13" name="Shape 11"/>
-          <p:cNvSpPr/>
-          <p:nvPr/>
-        </p:nvSpPr>
-        <p:spPr>
-          <a:xfrm>
-            <a:off x="3223260" y="2121408"/>
-            <a:ext cx="2697480" cy="2267712"/>
+              <a:t>Omri</a:t>
+            </a:r>
+            <a:endParaRPr lang="en-US" sz="1200" dirty="0"/>
+          </a:p>
+        </p:txBody>
+      </p:sp>
+      <p:sp>
+        <p:nvSpPr>
+          <p:cNvPr id="14" name="Shape 12"/>
+          <p:cNvSpPr/>
+          <p:nvPr/>
+        </p:nvSpPr>
+        <p:spPr>
+          <a:xfrm>
+            <a:off x="3223260" y="2761488"/>
+            <a:ext cx="2697480" cy="1673352"/>
           </a:xfrm>
           <a:prstGeom prst="rect">
             <a:avLst/>
@@ -5080,14 +5119,14 @@
       </p:sp>
       <p:sp>
         <p:nvSpPr>
-          <p:cNvPr id="14" name="Text 12"/>
-          <p:cNvSpPr/>
-          <p:nvPr/>
-        </p:nvSpPr>
-        <p:spPr>
-          <a:xfrm>
-            <a:off x="3406140" y="2267712"/>
-            <a:ext cx="2331720" cy="1993392"/>
+          <p:cNvPr id="15" name="Text 13"/>
+          <p:cNvSpPr/>
+          <p:nvPr/>
+        </p:nvSpPr>
+        <p:spPr>
+          <a:xfrm>
+            <a:off x="3387852" y="2907792"/>
+            <a:ext cx="2368296" cy="1417320"/>
           </a:xfrm>
           <a:prstGeom prst="rect">
             <a:avLst/>
@@ -5101,7 +5140,7 @@
           <a:p>
             <a:pPr marL="342900" indent="-342900">
               <a:spcAft>
-                <a:spcPts val="500"/>
+                <a:spcPts val="400"/>
               </a:spcAft>
               <a:buSzPct val="100000"/>
               <a:buChar char="■"/>
@@ -5115,14 +5154,14 @@
                 <a:ea typeface="Calibri" pitchFamily="34" charset="-122"/>
                 <a:cs typeface="Calibri" pitchFamily="34" charset="-120"/>
               </a:rPr>
-              <a:t>Owners: Javier + Omer Blechman</a:t>
+              <a:t>Competitor scan: where the market is moving</a:t>
             </a:r>
             <a:endParaRPr lang="en-US" sz="1100" dirty="0"/>
           </a:p>
           <a:p>
             <a:pPr marL="342900" indent="-342900">
               <a:spcAft>
-                <a:spcPts val="500"/>
+                <a:spcPts val="400"/>
               </a:spcAft>
               <a:buSzPct val="100000"/>
               <a:buChar char="■"/>
@@ -5136,14 +5175,14 @@
                 <a:ea typeface="Calibri" pitchFamily="34" charset="-122"/>
                 <a:cs typeface="Calibri" pitchFamily="34" charset="-120"/>
               </a:rPr>
-              <a:t>Options: build vs. adopt · M1/M2 inputs</a:t>
+              <a:t>Scope P0 remainder + post-P0 sequence</a:t>
             </a:r>
             <a:endParaRPr lang="en-US" sz="1100" dirty="0"/>
           </a:p>
           <a:p>
             <a:pPr marL="342900" indent="-342900">
               <a:spcAft>
-                <a:spcPts val="500"/>
+                <a:spcPts val="400"/>
               </a:spcAft>
               <a:buSzPct val="100000"/>
               <a:buChar char="■"/>
@@ -5157,14 +5196,14 @@
                 <a:ea typeface="Calibri" pitchFamily="34" charset="-122"/>
                 <a:cs typeface="Calibri" pitchFamily="34" charset="-120"/>
               </a:rPr>
-              <a:t>Apr 27 research → May 11 POC check</a:t>
+              <a:t>Define “demo lands” — format + scenario</a:t>
             </a:r>
             <a:endParaRPr lang="en-US" sz="1100" dirty="0"/>
           </a:p>
           <a:p>
             <a:pPr indent="0" marL="0">
               <a:spcAft>
-                <a:spcPts val="500"/>
+                <a:spcPts val="400"/>
               </a:spcAft>
               <a:buNone/>
             </a:pPr>
@@ -5177,7 +5216,7 @@
                 <a:ea typeface="Calibri" pitchFamily="34" charset="-122"/>
                 <a:cs typeface="Calibri" pitchFamily="34" charset="-120"/>
               </a:rPr>
-              <a:t>→ Jun 1 integration · Jun 15 demo</a:t>
+              <a:t>→ Share findings: Wednesday</a:t>
             </a:r>
             <a:endParaRPr lang="en-US" sz="1100" dirty="0"/>
           </a:p>
@@ -5185,14 +5224,14 @@
       </p:sp>
       <p:sp>
         <p:nvSpPr>
-          <p:cNvPr id="15" name="Shape 13"/>
-          <p:cNvSpPr/>
-          <p:nvPr/>
-        </p:nvSpPr>
-        <p:spPr>
-          <a:xfrm>
-            <a:off x="6039612" y="1645920"/>
-            <a:ext cx="2697480" cy="475488"/>
+          <p:cNvPr id="16" name="Shape 14"/>
+          <p:cNvSpPr/>
+          <p:nvPr/>
+        </p:nvSpPr>
+        <p:spPr>
+          <a:xfrm>
+            <a:off x="6012180" y="2103120"/>
+            <a:ext cx="2697480" cy="658368"/>
           </a:xfrm>
           <a:prstGeom prst="rect">
             <a:avLst/>
@@ -5210,30 +5249,69 @@
       </p:sp>
       <p:sp>
         <p:nvSpPr>
-          <p:cNvPr id="16" name="Text 14"/>
-          <p:cNvSpPr/>
-          <p:nvPr/>
-        </p:nvSpPr>
-        <p:spPr>
-          <a:xfrm>
-            <a:off x="6039612" y="1645920"/>
-            <a:ext cx="475488" cy="475488"/>
-          </a:xfrm>
-          <a:prstGeom prst="rect">
-            <a:avLst/>
-          </a:prstGeom>
-          <a:noFill/>
-          <a:ln/>
-        </p:spPr>
-        <p:txBody>
-          <a:bodyPr wrap="square" lIns="0" tIns="0" rIns="0" bIns="0" rtlCol="0" anchor="ctr"/>
-          <a:lstStyle/>
-          <a:p>
-            <a:pPr algn="ctr" indent="0" marL="0">
-              <a:buNone/>
-            </a:pPr>
-            <a:r>
-              <a:rPr lang="en-US" sz="2200" b="1" dirty="0">
+          <p:cNvPr id="17" name="Text 15"/>
+          <p:cNvSpPr/>
+          <p:nvPr/>
+        </p:nvSpPr>
+        <p:spPr>
+          <a:xfrm>
+            <a:off x="6149340" y="2148840"/>
+            <a:ext cx="2423160" cy="256032"/>
+          </a:xfrm>
+          <a:prstGeom prst="rect">
+            <a:avLst/>
+          </a:prstGeom>
+          <a:noFill/>
+          <a:ln/>
+        </p:spPr>
+        <p:txBody>
+          <a:bodyPr wrap="square" lIns="0" tIns="0" rIns="0" bIns="0" rtlCol="0" anchor="ctr"/>
+          <a:lstStyle/>
+          <a:p>
+            <a:pPr indent="0" marL="0">
+              <a:buNone/>
+            </a:pPr>
+            <a:r>
+              <a:rPr lang="en-US" sz="1000" b="1" spc="300" kern="0" dirty="0">
+                <a:solidFill>
+                  <a:srgbClr val="0F1B3D"/>
+                </a:solidFill>
+                <a:latin typeface="Calibri" pitchFamily="34" charset="0"/>
+                <a:ea typeface="Calibri" pitchFamily="34" charset="-122"/>
+                <a:cs typeface="Calibri" pitchFamily="34" charset="-120"/>
+              </a:rPr>
+              <a:t>ARCHITECTURE</a:t>
+            </a:r>
+            <a:endParaRPr lang="en-US" sz="1000" dirty="0"/>
+          </a:p>
+        </p:txBody>
+      </p:sp>
+      <p:sp>
+        <p:nvSpPr>
+          <p:cNvPr id="18" name="Text 16"/>
+          <p:cNvSpPr/>
+          <p:nvPr/>
+        </p:nvSpPr>
+        <p:spPr>
+          <a:xfrm>
+            <a:off x="6149340" y="2450592"/>
+            <a:ext cx="2423160" cy="256032"/>
+          </a:xfrm>
+          <a:prstGeom prst="rect">
+            <a:avLst/>
+          </a:prstGeom>
+          <a:noFill/>
+          <a:ln/>
+        </p:spPr>
+        <p:txBody>
+          <a:bodyPr wrap="square" lIns="0" tIns="0" rIns="0" bIns="0" rtlCol="0" anchor="ctr"/>
+          <a:lstStyle/>
+          <a:p>
+            <a:pPr indent="0" marL="0">
+              <a:buNone/>
+            </a:pPr>
+            <a:r>
+              <a:rPr lang="en-US" sz="1200" b="1" dirty="0">
                 <a:solidFill>
                   <a:srgbClr val="0F1B3D"/>
                 </a:solidFill>
@@ -5241,61 +5319,22 @@
                 <a:ea typeface="Georgia" pitchFamily="34" charset="-122"/>
                 <a:cs typeface="Georgia" pitchFamily="34" charset="-120"/>
               </a:rPr>
-              <a:t>C</a:t>
-            </a:r>
-            <a:endParaRPr lang="en-US" sz="2200" dirty="0"/>
-          </a:p>
-        </p:txBody>
-      </p:sp>
-      <p:sp>
-        <p:nvSpPr>
-          <p:cNvPr id="17" name="Text 15"/>
-          <p:cNvSpPr/>
-          <p:nvPr/>
-        </p:nvSpPr>
-        <p:spPr>
-          <a:xfrm>
-            <a:off x="6569964" y="1709928"/>
-            <a:ext cx="2103120" cy="384048"/>
-          </a:xfrm>
-          <a:prstGeom prst="rect">
-            <a:avLst/>
-          </a:prstGeom>
-          <a:noFill/>
-          <a:ln/>
-        </p:spPr>
-        <p:txBody>
-          <a:bodyPr wrap="square" lIns="0" tIns="0" rIns="0" bIns="0" rtlCol="0" anchor="ctr"/>
-          <a:lstStyle/>
-          <a:p>
-            <a:pPr indent="0" marL="0">
-              <a:buNone/>
-            </a:pPr>
-            <a:r>
-              <a:rPr lang="en-US" sz="1400" b="1" dirty="0">
-                <a:solidFill>
-                  <a:srgbClr val="0F1B3D"/>
-                </a:solidFill>
-                <a:latin typeface="Georgia" pitchFamily="34" charset="0"/>
-                <a:ea typeface="Georgia" pitchFamily="34" charset="-122"/>
-                <a:cs typeface="Georgia" pitchFamily="34" charset="-120"/>
-              </a:rPr>
-              <a:t>Demo format picked</a:t>
-            </a:r>
-            <a:endParaRPr lang="en-US" sz="1400" dirty="0"/>
-          </a:p>
-        </p:txBody>
-      </p:sp>
-      <p:sp>
-        <p:nvSpPr>
-          <p:cNvPr id="18" name="Shape 16"/>
-          <p:cNvSpPr/>
-          <p:nvPr/>
-        </p:nvSpPr>
-        <p:spPr>
-          <a:xfrm>
-            <a:off x="6039612" y="2121408"/>
-            <a:ext cx="2697480" cy="2267712"/>
+              <a:t>Sarit + Amir Ben Ami</a:t>
+            </a:r>
+            <a:endParaRPr lang="en-US" sz="1200" dirty="0"/>
+          </a:p>
+        </p:txBody>
+      </p:sp>
+      <p:sp>
+        <p:nvSpPr>
+          <p:cNvPr id="19" name="Shape 17"/>
+          <p:cNvSpPr/>
+          <p:nvPr/>
+        </p:nvSpPr>
+        <p:spPr>
+          <a:xfrm>
+            <a:off x="6012180" y="2761488"/>
+            <a:ext cx="2697480" cy="1673352"/>
           </a:xfrm>
           <a:prstGeom prst="rect">
             <a:avLst/>
@@ -5313,14 +5352,14 @@
       </p:sp>
       <p:sp>
         <p:nvSpPr>
-          <p:cNvPr id="19" name="Text 17"/>
-          <p:cNvSpPr/>
-          <p:nvPr/>
-        </p:nvSpPr>
-        <p:spPr>
-          <a:xfrm>
-            <a:off x="6222492" y="2267712"/>
-            <a:ext cx="2331720" cy="1993392"/>
+          <p:cNvPr id="20" name="Text 18"/>
+          <p:cNvSpPr/>
+          <p:nvPr/>
+        </p:nvSpPr>
+        <p:spPr>
+          <a:xfrm>
+            <a:off x="6176772" y="2907792"/>
+            <a:ext cx="2368296" cy="1417320"/>
           </a:xfrm>
           <a:prstGeom prst="rect">
             <a:avLst/>
@@ -5334,7 +5373,7 @@
           <a:p>
             <a:pPr marL="342900" indent="-342900">
               <a:spcAft>
-                <a:spcPts val="500"/>
+                <a:spcPts val="400"/>
               </a:spcAft>
               <a:buSzPct val="100000"/>
               <a:buChar char="■"/>
@@ -5348,14 +5387,14 @@
                 <a:ea typeface="Calibri" pitchFamily="34" charset="-122"/>
                 <a:cs typeface="Calibri" pitchFamily="34" charset="-120"/>
               </a:rPr>
-              <a:t>Thin live: Gateway + 1 connector + 1 policy, live</a:t>
+              <a:t>Gateway design doc: surface + policy model</a:t>
             </a:r>
             <a:endParaRPr lang="en-US" sz="1100" dirty="0"/>
           </a:p>
           <a:p>
             <a:pPr marL="342900" indent="-342900">
               <a:spcAft>
-                <a:spcPts val="500"/>
+                <a:spcPts val="400"/>
               </a:spcAft>
               <a:buSzPct val="100000"/>
               <a:buChar char="■"/>
@@ -5369,14 +5408,14 @@
                 <a:ea typeface="Calibri" pitchFamily="34" charset="-122"/>
                 <a:cs typeface="Calibri" pitchFamily="34" charset="-120"/>
               </a:rPr>
-              <a:t>Wide canned: all 3 components, scripted</a:t>
+              <a:t>Tool-level access model for Policy Agent</a:t>
             </a:r>
             <a:endParaRPr lang="en-US" sz="1100" dirty="0"/>
           </a:p>
           <a:p>
             <a:pPr marL="342900" indent="-342900">
               <a:spcAft>
-                <a:spcPts val="500"/>
+                <a:spcPts val="400"/>
               </a:spcAft>
               <a:buSzPct val="100000"/>
               <a:buChar char="■"/>
@@ -5390,14 +5429,14 @@
                 <a:ea typeface="Calibri" pitchFamily="34" charset="-122"/>
                 <a:cs typeface="Calibri" pitchFamily="34" charset="-120"/>
               </a:rPr>
-              <a:t>Hybrid: Gateway live, rest scripted</a:t>
+              <a:t>Integration points with eng research</a:t>
             </a:r>
             <a:endParaRPr lang="en-US" sz="1100" dirty="0"/>
           </a:p>
           <a:p>
             <a:pPr indent="0" marL="0">
               <a:spcAft>
-                <a:spcPts val="500"/>
+                <a:spcPts val="400"/>
               </a:spcAft>
               <a:buNone/>
             </a:pPr>
@@ -5410,7 +5449,7 @@
                 <a:ea typeface="Calibri" pitchFamily="34" charset="-122"/>
                 <a:cs typeface="Calibri" pitchFamily="34" charset="-120"/>
               </a:rPr>
-              <a:t>→ Room picks one</a:t>
+              <a:t>→ This week</a:t>
             </a:r>
             <a:endParaRPr lang="en-US" sz="1100" dirty="0"/>
           </a:p>
@@ -5418,24 +5457,24 @@
       </p:sp>
       <p:sp>
         <p:nvSpPr>
-          <p:cNvPr id="20" name="Shape 18"/>
-          <p:cNvSpPr/>
-          <p:nvPr/>
-        </p:nvSpPr>
-        <p:spPr>
-          <a:xfrm>
-            <a:off x="457200" y="4544568"/>
+          <p:cNvPr id="21" name="Shape 19"/>
+          <p:cNvSpPr/>
+          <p:nvPr/>
+        </p:nvSpPr>
+        <p:spPr>
+          <a:xfrm>
+            <a:off x="457200" y="4572000"/>
             <a:ext cx="8229600" cy="384048"/>
           </a:xfrm>
           <a:prstGeom prst="rect">
             <a:avLst/>
           </a:prstGeom>
           <a:solidFill>
-            <a:srgbClr val="02C39A"/>
+            <a:srgbClr val="F59E0B"/>
           </a:solidFill>
           <a:ln w="12700">
             <a:solidFill>
-              <a:srgbClr val="02C39A"/>
+              <a:srgbClr val="F59E0B"/>
             </a:solidFill>
             <a:prstDash val="solid"/>
           </a:ln>
@@ -5443,13 +5482,13 @@
       </p:sp>
       <p:sp>
         <p:nvSpPr>
-          <p:cNvPr id="21" name="Text 19"/>
-          <p:cNvSpPr/>
-          <p:nvPr/>
-        </p:nvSpPr>
-        <p:spPr>
-          <a:xfrm>
-            <a:off x="640080" y="4544568"/>
+          <p:cNvPr id="22" name="Text 20"/>
+          <p:cNvSpPr/>
+          <p:nvPr/>
+        </p:nvSpPr>
+        <p:spPr>
+          <a:xfrm>
+            <a:off x="640080" y="4572000"/>
             <a:ext cx="7863840" cy="384048"/>
           </a:xfrm>
           <a:prstGeom prst="rect">
@@ -5466,7 +5505,7 @@
               <a:buNone/>
             </a:pPr>
             <a:r>
-              <a:rPr lang="en-US" sz="1000" b="1" spc="300" kern="0" dirty="0">
+              <a:rPr lang="en-US" sz="1100" b="1" spc="300" kern="0" dirty="0">
                 <a:solidFill>
                   <a:srgbClr val="0F1B3D"/>
                 </a:solidFill>
@@ -5474,13 +5513,13 @@
                 <a:ea typeface="Calibri" pitchFamily="34" charset="-122"/>
                 <a:cs typeface="Calibri" pitchFamily="34" charset="-120"/>
               </a:rPr>
-              <a:t>OPEN TO THE ROOM:  </a:t>
-            </a:r>
-            <a:pPr indent="0" marL="0">
-              <a:buNone/>
-            </a:pPr>
-            <a:r>
-              <a:rPr lang="en-US" sz="1300" b="1" i="1" dirty="0">
+              <a:t>P0 FOR LINX  ·  </a:t>
+            </a:r>
+            <a:pPr indent="0" marL="0">
+              <a:buNone/>
+            </a:pPr>
+            <a:r>
+              <a:rPr lang="en-US" sz="1300" dirty="0">
                 <a:solidFill>
                   <a:srgbClr val="0F1B3D"/>
                 </a:solidFill>
@@ -5488,15 +5527,29 @@
                 <a:ea typeface="Calibri" pitchFamily="34" charset="-122"/>
                 <a:cs typeface="Calibri" pitchFamily="34" charset="-120"/>
               </a:rPr>
-              <a:t>What from M1 / M2 already covers parts of P0? What do you think is missing?</a:t>
-            </a:r>
-            <a:endParaRPr lang="en-US" sz="1000" dirty="0"/>
-          </a:p>
-        </p:txBody>
-      </p:sp>
-      <p:sp>
-        <p:nvSpPr>
-          <p:cNvPr id="22" name="Text 20"/>
+              <a:t>Omri + Sarit tracking weekly  ·  June 15 is the line  ·  </a:t>
+            </a:r>
+            <a:pPr indent="0" marL="0">
+              <a:buNone/>
+            </a:pPr>
+            <a:r>
+              <a:rPr lang="en-US" sz="1300" b="1" dirty="0">
+                <a:solidFill>
+                  <a:srgbClr val="0F1B3D"/>
+                </a:solidFill>
+                <a:latin typeface="Calibri" pitchFamily="34" charset="0"/>
+                <a:ea typeface="Calibri" pitchFamily="34" charset="-122"/>
+                <a:cs typeface="Calibri" pitchFamily="34" charset="-120"/>
+              </a:rPr>
+              <a:t>Next full sync after Wednesday research check-in.</a:t>
+            </a:r>
+            <a:endParaRPr lang="en-US" sz="1100" dirty="0"/>
+          </a:p>
+        </p:txBody>
+      </p:sp>
+      <p:sp>
+        <p:nvSpPr>
+          <p:cNvPr id="23" name="Text 21"/>
           <p:cNvSpPr/>
           <p:nvPr/>
         </p:nvSpPr>

</xml_diff>